<commit_message>
Update presentation (.pptx) with Tumakuru 35 wards and Admin ID/Password workflow
</commit_message>
<xml_diff>
--- a/CitizenShield_Presentation.pptx
+++ b/CitizenShield_Presentation.pptx
@@ -3174,7 +3174,7 @@
               </a:defRPr>
             </a:pPr>
             <a:r>
-              <a:t>CIVIC TECH • SMART MUNICIPAL GOVERNANCE</a:t>
+              <a:t>CIVIC TECH • SMART MUNICIPAL GOVERNANCE • TUMAKURU CITY CORPORATION</a:t>
             </a:r>
           </a:p>
           <a:p>
@@ -3204,7 +3204,7 @@
               </a:defRPr>
             </a:pPr>
             <a:r>
-              <a:t>Next-Generation Municipal Grievance Redressal &amp; Spatial Radar Platform</a:t>
+              <a:t>Smart Municipal Grievance Redressal &amp; Spatial Radar Platform (35 Wards)</a:t>
             </a:r>
           </a:p>
           <a:p>
@@ -3322,7 +3322,7 @@
               </a:defRPr>
             </a:pPr>
             <a:r>
-              <a:t>ROADMAP</a:t>
+              <a:t>VERIFICATION</a:t>
             </a:r>
           </a:p>
         </p:txBody>
@@ -3358,7 +3358,7 @@
               </a:defRPr>
             </a:pPr>
             <a:r>
-              <a:t>Future Roadmap: Smart City Integrations</a:t>
+              <a:t>Comprehensive Testing &amp; Quality Verification</a:t>
             </a:r>
           </a:p>
         </p:txBody>
@@ -3417,7 +3417,7 @@
         <p:spPr>
           <a:xfrm>
             <a:off x="731520" y="1645920"/>
-            <a:ext cx="5120640" cy="4572000"/>
+            <a:ext cx="3383280" cy="4572000"/>
           </a:xfrm>
           <a:prstGeom prst="roundRect">
             <a:avLst/>
@@ -3462,7 +3462,7 @@
         <p:spPr>
           <a:xfrm>
             <a:off x="914400" y="1828800"/>
-            <a:ext cx="4754880" cy="4206240"/>
+            <a:ext cx="3017520" cy="4206240"/>
           </a:xfrm>
           <a:prstGeom prst="rect">
             <a:avLst/>
@@ -3484,55 +3484,55 @@
               </a:defRPr>
             </a:pPr>
             <a:r>
-              <a:t>[AI / ML] Phase 1: AI &amp; IoT Integration</a:t>
-            </a:r>
-          </a:p>
-          <a:p>
-            <a:pPr>
-              <a:spcBef>
-                <a:spcPts val="800"/>
-              </a:spcBef>
-              <a:defRPr sz="1300">
-                <a:solidFill>
-                  <a:srgbClr val="FFFFFF"/>
-                </a:solidFill>
-                <a:latin typeface="Arial"/>
-              </a:defRPr>
-            </a:pPr>
-            <a:r>
-              <a:t>• Computer Vision Pothole Detection: Automatic depth and severity scoring from uploaded photos.</a:t>
-            </a:r>
-          </a:p>
-          <a:p>
-            <a:pPr>
-              <a:spcBef>
-                <a:spcPts val="800"/>
-              </a:spcBef>
-              <a:defRPr sz="1300">
-                <a:solidFill>
-                  <a:srgbClr val="FFFFFF"/>
-                </a:solidFill>
-                <a:latin typeface="Arial"/>
-              </a:defRPr>
-            </a:pPr>
-            <a:r>
-              <a:t>• WhatsApp Grievance Bot: Direct lodging via Twilio WhatsApp API for citizens without web access.</a:t>
-            </a:r>
-          </a:p>
-          <a:p>
-            <a:pPr>
-              <a:spcBef>
-                <a:spcPts val="800"/>
-              </a:spcBef>
-              <a:defRPr sz="1300">
-                <a:solidFill>
-                  <a:srgbClr val="FFFFFF"/>
-                </a:solidFill>
-                <a:latin typeface="Arial"/>
-              </a:defRPr>
-            </a:pPr>
-            <a:r>
-              <a:t>• Smart Streetlight Telemetry: Automated defect logging via IoT power sensors.</a:t>
+              <a:t>[FRONTEND] Automated ID Audit</a:t>
+            </a:r>
+          </a:p>
+          <a:p>
+            <a:pPr>
+              <a:spcBef>
+                <a:spcPts val="800"/>
+              </a:spcBef>
+              <a:defRPr sz="1300">
+                <a:solidFill>
+                  <a:srgbClr val="FFFFFF"/>
+                </a:solidFill>
+                <a:latin typeface="Arial"/>
+              </a:defRPr>
+            </a:pPr>
+            <a:r>
+              <a:t>• 111+ HTML DOM Element IDs matched with JavaScript controllers.</a:t>
+            </a:r>
+          </a:p>
+          <a:p>
+            <a:pPr>
+              <a:spcBef>
+                <a:spcPts val="800"/>
+              </a:spcBef>
+              <a:defRPr sz="1300">
+                <a:solidFill>
+                  <a:srgbClr val="FFFFFF"/>
+                </a:solidFill>
+                <a:latin typeface="Arial"/>
+              </a:defRPr>
+            </a:pPr>
+            <a:r>
+              <a:t>• 0 missing IDs, 0 null-pointer crashes.</a:t>
+            </a:r>
+          </a:p>
+          <a:p>
+            <a:pPr>
+              <a:spcBef>
+                <a:spcPts val="800"/>
+              </a:spcBef>
+              <a:defRPr sz="1300">
+                <a:solidFill>
+                  <a:srgbClr val="FFFFFF"/>
+                </a:solidFill>
+                <a:latin typeface="Arial"/>
+              </a:defRPr>
+            </a:pPr>
+            <a:r>
+              <a:t>• Tested across modern Chromium, Gecko, and WebKit browsers.</a:t>
             </a:r>
           </a:p>
         </p:txBody>
@@ -3545,8 +3545,8 @@
         </p:nvSpPr>
         <p:spPr>
           <a:xfrm>
-            <a:off x="6217920" y="1645920"/>
-            <a:ext cx="5120640" cy="4572000"/>
+            <a:off x="4389120" y="1645920"/>
+            <a:ext cx="3383280" cy="4572000"/>
           </a:xfrm>
           <a:prstGeom prst="roundRect">
             <a:avLst/>
@@ -3590,8 +3590,8 @@
         </p:nvSpPr>
         <p:spPr>
           <a:xfrm>
-            <a:off x="6400800" y="1828800"/>
-            <a:ext cx="4754880" cy="4206240"/>
+            <a:off x="4572000" y="1828800"/>
+            <a:ext cx="3017520" cy="4206240"/>
           </a:xfrm>
           <a:prstGeom prst="rect">
             <a:avLst/>
@@ -3613,55 +3613,184 @@
               </a:defRPr>
             </a:pPr>
             <a:r>
-              <a:t>[ENTERPRISE] Phase 2: Government ERP Integration</a:t>
-            </a:r>
-          </a:p>
-          <a:p>
-            <a:pPr>
-              <a:spcBef>
-                <a:spcPts val="800"/>
-              </a:spcBef>
-              <a:defRPr sz="1300">
-                <a:solidFill>
-                  <a:srgbClr val="FFFFFF"/>
-                </a:solidFill>
-                <a:latin typeface="Arial"/>
-              </a:defRPr>
-            </a:pPr>
-            <a:r>
-              <a:t>• BBMP Sahaaya &amp; BESCOM SCADA API Synchronization.</a:t>
-            </a:r>
-          </a:p>
-          <a:p>
-            <a:pPr>
-              <a:spcBef>
-                <a:spcPts val="800"/>
-              </a:spcBef>
-              <a:defRPr sz="1300">
-                <a:solidFill>
-                  <a:srgbClr val="FFFFFF"/>
-                </a:solidFill>
-                <a:latin typeface="Arial"/>
-              </a:defRPr>
-            </a:pPr>
-            <a:r>
-              <a:t>• Automated Contractor SLA Penalties for delayed resolution beyond 72 hours.</a:t>
-            </a:r>
-          </a:p>
-          <a:p>
-            <a:pPr>
-              <a:spcBef>
-                <a:spcPts val="800"/>
-              </a:spcBef>
-              <a:defRPr sz="1300">
-                <a:solidFill>
-                  <a:srgbClr val="FFFFFF"/>
-                </a:solidFill>
-                <a:latin typeface="Arial"/>
-              </a:defRPr>
-            </a:pPr>
-            <a:r>
-              <a:t>• Civic Incentive Badges: Gamified citizen rewards for high-impact neighborhood vigilance.</a:t>
+              <a:t>[BACKEND] API Stress Testing</a:t>
+            </a:r>
+          </a:p>
+          <a:p>
+            <a:pPr>
+              <a:spcBef>
+                <a:spcPts val="800"/>
+              </a:spcBef>
+              <a:defRPr sz="1300">
+                <a:solidFill>
+                  <a:srgbClr val="FFFFFF"/>
+                </a:solidFill>
+                <a:latin typeface="Arial"/>
+              </a:defRPr>
+            </a:pPr>
+            <a:r>
+              <a:t>• HTTP 200 OK verified across all 8 REST API endpoints.</a:t>
+            </a:r>
+          </a:p>
+          <a:p>
+            <a:pPr>
+              <a:spcBef>
+                <a:spcPts val="800"/>
+              </a:spcBef>
+              <a:defRPr sz="1300">
+                <a:solidFill>
+                  <a:srgbClr val="FFFFFF"/>
+                </a:solidFill>
+                <a:latin typeface="Arial"/>
+              </a:defRPr>
+            </a:pPr>
+            <a:r>
+              <a:t>• Sub-15ms response latency for SQLite WAL queries.</a:t>
+            </a:r>
+          </a:p>
+          <a:p>
+            <a:pPr>
+              <a:spcBef>
+                <a:spcPts val="800"/>
+              </a:spcBef>
+              <a:defRPr sz="1300">
+                <a:solidFill>
+                  <a:srgbClr val="FFFFFF"/>
+                </a:solidFill>
+                <a:latin typeface="Arial"/>
+              </a:defRPr>
+            </a:pPr>
+            <a:r>
+              <a:t>• Graceful handling of multi-part photo uploads up to 10MB.</a:t>
+            </a:r>
+          </a:p>
+        </p:txBody>
+      </p:sp>
+      <p:sp>
+        <p:nvSpPr>
+          <p:cNvPr id="10" name="Rounded Rectangle 9"/>
+          <p:cNvSpPr/>
+          <p:nvPr/>
+        </p:nvSpPr>
+        <p:spPr>
+          <a:xfrm>
+            <a:off x="8046720" y="1645920"/>
+            <a:ext cx="3383280" cy="4572000"/>
+          </a:xfrm>
+          <a:prstGeom prst="roundRect">
+            <a:avLst/>
+          </a:prstGeom>
+          <a:solidFill>
+            <a:srgbClr val="081C26"/>
+          </a:solidFill>
+          <a:ln w="12700">
+            <a:solidFill>
+              <a:srgbClr val="2DD4BF"/>
+            </a:solidFill>
+          </a:ln>
+        </p:spPr>
+        <p:style>
+          <a:lnRef idx="1">
+            <a:schemeClr val="accent1"/>
+          </a:lnRef>
+          <a:fillRef idx="3">
+            <a:schemeClr val="accent1"/>
+          </a:fillRef>
+          <a:effectRef idx="2">
+            <a:schemeClr val="accent1"/>
+          </a:effectRef>
+          <a:fontRef idx="minor">
+            <a:schemeClr val="lt1"/>
+          </a:fontRef>
+        </p:style>
+        <p:txBody>
+          <a:bodyPr rtlCol="0" anchor="ctr"/>
+          <a:lstStyle/>
+          <a:p>
+            <a:pPr algn="ctr"/>
+          </a:p>
+        </p:txBody>
+      </p:sp>
+      <p:sp>
+        <p:nvSpPr>
+          <p:cNvPr id="11" name="TextBox 10"/>
+          <p:cNvSpPr txBox="1"/>
+          <p:nvPr/>
+        </p:nvSpPr>
+        <p:spPr>
+          <a:xfrm>
+            <a:off x="8229600" y="1828800"/>
+            <a:ext cx="3017520" cy="4206240"/>
+          </a:xfrm>
+          <a:prstGeom prst="rect">
+            <a:avLst/>
+          </a:prstGeom>
+          <a:noFill/>
+        </p:spPr>
+        <p:txBody>
+          <a:bodyPr wrap="square">
+            <a:spAutoFit/>
+          </a:bodyPr>
+          <a:lstStyle/>
+          <a:p>
+            <a:pPr>
+              <a:defRPr sz="1600" b="1">
+                <a:solidFill>
+                  <a:srgbClr val="2DD4BF"/>
+                </a:solidFill>
+                <a:latin typeface="Arial"/>
+              </a:defRPr>
+            </a:pPr>
+            <a:r>
+              <a:t>[STORAGE] Persistence Test</a:t>
+            </a:r>
+          </a:p>
+          <a:p>
+            <a:pPr>
+              <a:spcBef>
+                <a:spcPts val="800"/>
+              </a:spcBef>
+              <a:defRPr sz="1300">
+                <a:solidFill>
+                  <a:srgbClr val="FFFFFF"/>
+                </a:solidFill>
+                <a:latin typeface="Arial"/>
+              </a:defRPr>
+            </a:pPr>
+            <a:r>
+              <a:t>• Server restart survival verified.</a:t>
+            </a:r>
+          </a:p>
+          <a:p>
+            <a:pPr>
+              <a:spcBef>
+                <a:spcPts val="800"/>
+              </a:spcBef>
+              <a:defRPr sz="1300">
+                <a:solidFill>
+                  <a:srgbClr val="FFFFFF"/>
+                </a:solidFill>
+                <a:latin typeface="Arial"/>
+              </a:defRPr>
+            </a:pPr>
+            <a:r>
+              <a:t>• Zero data loss across daemon restarts.</a:t>
+            </a:r>
+          </a:p>
+          <a:p>
+            <a:pPr>
+              <a:spcBef>
+                <a:spcPts val="800"/>
+              </a:spcBef>
+              <a:defRPr sz="1300">
+                <a:solidFill>
+                  <a:srgbClr val="FFFFFF"/>
+                </a:solidFill>
+                <a:latin typeface="Arial"/>
+              </a:defRPr>
+            </a:pPr>
+            <a:r>
+              <a:t>• Git repository synced cleanly to GitHub.</a:t>
             </a:r>
           </a:p>
         </p:txBody>
@@ -3938,39 +4067,39 @@
               </a:defRPr>
             </a:pPr>
             <a:r>
-              <a:t>• 1. Open http://localhost:5000: Showcase the 3D Dotted Earth Globe, interactively drag to rotate, point out Bengaluru Ward 112 pulsing beacon and live coordinate telemetry readout.</a:t>
-            </a:r>
-          </a:p>
-          <a:p>
-            <a:pPr>
-              <a:spcBef>
-                <a:spcPts val="800"/>
-              </a:spcBef>
-              <a:defRPr sz="1300">
-                <a:solidFill>
-                  <a:srgbClr val="FFFFFF"/>
-                </a:solidFill>
-                <a:latin typeface="Arial"/>
-              </a:defRPr>
-            </a:pPr>
-            <a:r>
-              <a:t>• 2. Explain Safety Banner: Highlight the executive emergency ribbon directing crime/fire to 112 while reserving the platform for civic infrastructure defects.</a:t>
-            </a:r>
-          </a:p>
-          <a:p>
-            <a:pPr>
-              <a:spcBef>
-                <a:spcPts val="800"/>
-              </a:spcBef>
-              <a:defRPr sz="1300">
-                <a:solidFill>
-                  <a:srgbClr val="FFFFFF"/>
-                </a:solidFill>
-                <a:latin typeface="Arial"/>
-              </a:defRPr>
-            </a:pPr>
-            <a:r>
-              <a:t>• 3. Lodge Grievance: Demonstrate GPS pinpointing on Leaflet map, select 'Roads &amp; Craters', upload evidence photo, and submit to SQLite vault.</a:t>
+              <a:t>• 1. Open http://localhost:5000: Showcase the 3D Dotted Earth Globe, interactively drag to rotate, click 'Target Tumakuru' to center on Tumakuru Corporation coords (13.3414° N, 77.1022° E).</a:t>
+            </a:r>
+          </a:p>
+          <a:p>
+            <a:pPr>
+              <a:spcBef>
+                <a:spcPts val="800"/>
+              </a:spcBef>
+              <a:defRPr sz="1300">
+                <a:solidFill>
+                  <a:srgbClr val="FFFFFF"/>
+                </a:solidFill>
+                <a:latin typeface="Arial"/>
+              </a:defRPr>
+            </a:pPr>
+            <a:r>
+              <a:t>• 2. Explain Safety Directive: Highlight the executive emergency ribbon directing crime/fire to 112 while reserving the platform for civic infrastructure defects.</a:t>
+            </a:r>
+          </a:p>
+          <a:p>
+            <a:pPr>
+              <a:spcBef>
+                <a:spcPts val="800"/>
+              </a:spcBef>
+              <a:defRPr sz="1300">
+                <a:solidFill>
+                  <a:srgbClr val="FFFFFF"/>
+                </a:solidFill>
+                <a:latin typeface="Arial"/>
+              </a:defRPr>
+            </a:pPr>
+            <a:r>
+              <a:t>• 3. Lodge Grievance: Demonstrate GPS pinpointing on Leaflet map, choose from all 35 Tumakuru Corporation wards (e.g. Ward 18 - SIT Campus), upload evidence photo, and submit to SQLite vault.</a:t>
             </a:r>
           </a:p>
           <a:p>
@@ -4002,7 +4131,7 @@
               </a:defRPr>
             </a:pPr>
             <a:r>
-              <a:t>• 5. Officer Console: Switch to Municipal Officer Console, filter by Ward 112 / Urgent priority, and update the status with official work order remarks.</a:t>
+              <a:t>• 5. Officer Console: Log in as admin@citizenshield.gov / admin123, filter by Ward / Severity, and update the status to 'Resolved' with official work order remarks.</a:t>
             </a:r>
           </a:p>
           <a:p>
@@ -4327,6 +4456,22 @@
               </a:defRPr>
             </a:pPr>
             <a:r>
+              <a:t>• Comprehensive coverage of all 35 Tumakuru City Corporation wards.</a:t>
+            </a:r>
+          </a:p>
+          <a:p>
+            <a:pPr>
+              <a:spcBef>
+                <a:spcPts val="800"/>
+              </a:spcBef>
+              <a:defRPr sz="1300">
+                <a:solidFill>
+                  <a:srgbClr val="FFFFFF"/>
+                </a:solidFill>
+                <a:latin typeface="Arial"/>
+              </a:defRPr>
+            </a:pPr>
+            <a:r>
               <a:t>• Unique, non-generic glassmorphic UI with bespoke 3D Dotted Earth math engine.</a:t>
             </a:r>
           </a:p>
@@ -4344,22 +4489,6 @@
             </a:pPr>
             <a:r>
               <a:t>• Full role-based security, GIS spatial integration, and printable legal certificates.</a:t>
-            </a:r>
-          </a:p>
-          <a:p>
-            <a:pPr>
-              <a:spcBef>
-                <a:spcPts val="800"/>
-              </a:spcBef>
-              <a:defRPr sz="1300">
-                <a:solidFill>
-                  <a:srgbClr val="FFFFFF"/>
-                </a:solidFill>
-                <a:latin typeface="Arial"/>
-              </a:defRPr>
-            </a:pPr>
-            <a:r>
-              <a:t>• Clean code structure adhering to industry best practices.</a:t>
             </a:r>
           </a:p>
         </p:txBody>
@@ -4488,23 +4617,23 @@
               </a:defRPr>
             </a:pPr>
             <a:r>
-              <a:t>• Default Officer Account: officer@citizenshield.gov / officer123</a:t>
-            </a:r>
-          </a:p>
-          <a:p>
-            <a:pPr>
-              <a:spcBef>
-                <a:spcPts val="800"/>
-              </a:spcBef>
-              <a:defRPr sz="1300">
-                <a:solidFill>
-                  <a:srgbClr val="FFFFFF"/>
-                </a:solidFill>
-                <a:latin typeface="Arial"/>
-              </a:defRPr>
-            </a:pPr>
-            <a:r>
-              <a:t>• Default Citizen Account: ananya.sharma@example.in / citizen123</a:t>
+              <a:t>• Directorate Admin: admin@citizenshield.gov / admin123</a:t>
+            </a:r>
+          </a:p>
+          <a:p>
+            <a:pPr>
+              <a:spcBef>
+                <a:spcPts val="800"/>
+              </a:spcBef>
+              <a:defRPr sz="1300">
+                <a:solidFill>
+                  <a:srgbClr val="FFFFFF"/>
+                </a:solidFill>
+                <a:latin typeface="Arial"/>
+              </a:defRPr>
+            </a:pPr>
+            <a:r>
+              <a:t>• Default Citizen: rahul.citizen@gmail.com / Citizen@2026</a:t>
             </a:r>
           </a:p>
           <a:p>
@@ -4671,7 +4800,7 @@
               </a:defRPr>
             </a:pPr>
             <a:r>
-              <a:t>The Problem Statement: Urban Infrastructure Deficit</a:t>
+              <a:t>The Problem Statement: Urban Civic Deficit</a:t>
             </a:r>
           </a:p>
         </p:txBody>
@@ -4813,55 +4942,55 @@
               </a:defRPr>
             </a:pPr>
             <a:r>
-              <a:t>• Citizens report craters, sewage spills, and blackouts via unmonitored WhatsApp, calls, or social media.</a:t>
-            </a:r>
-          </a:p>
-          <a:p>
-            <a:pPr>
-              <a:spcBef>
-                <a:spcPts val="800"/>
-              </a:spcBef>
-              <a:defRPr sz="1300">
-                <a:solidFill>
-                  <a:srgbClr val="FFFFFF"/>
-                </a:solidFill>
-                <a:latin typeface="Arial"/>
-              </a:defRPr>
-            </a:pPr>
-            <a:r>
-              <a:t>• Zero tracking mechanism: 82% of citizens never know if their complaint reached an authorized officer.</a:t>
-            </a:r>
-          </a:p>
-          <a:p>
-            <a:pPr>
-              <a:spcBef>
-                <a:spcPts val="800"/>
-              </a:spcBef>
-              <a:defRPr sz="1300">
-                <a:solidFill>
-                  <a:srgbClr val="FFFFFF"/>
-                </a:solidFill>
-                <a:latin typeface="Arial"/>
-              </a:defRPr>
-            </a:pPr>
-            <a:r>
-              <a:t>• Duplicate lodging: Multiple citizens submit redundant complaints for the same road hazard.</a:t>
-            </a:r>
-          </a:p>
-          <a:p>
-            <a:pPr>
-              <a:spcBef>
-                <a:spcPts val="800"/>
-              </a:spcBef>
-              <a:defRPr sz="1300">
-                <a:solidFill>
-                  <a:srgbClr val="FFFFFF"/>
-                </a:solidFill>
-                <a:latin typeface="Arial"/>
-              </a:defRPr>
-            </a:pPr>
-            <a:r>
-              <a:t>• Total lack of spatial context: Address descriptions like 'near old tea stall' delay field teams by days.</a:t>
+              <a:t>• Citizens report craters, sewage bursts, and dark streetlights through scattered calls, social media, or verbal complaints.</a:t>
+            </a:r>
+          </a:p>
+          <a:p>
+            <a:pPr>
+              <a:spcBef>
+                <a:spcPts val="800"/>
+              </a:spcBef>
+              <a:defRPr sz="1300">
+                <a:solidFill>
+                  <a:srgbClr val="FFFFFF"/>
+                </a:solidFill>
+                <a:latin typeface="Arial"/>
+              </a:defRPr>
+            </a:pPr>
+            <a:r>
+              <a:t>• Zero tracking mechanism: 80%+ citizens never receive an update once a complaint is made.</a:t>
+            </a:r>
+          </a:p>
+          <a:p>
+            <a:pPr>
+              <a:spcBef>
+                <a:spcPts val="800"/>
+              </a:spcBef>
+              <a:defRPr sz="1300">
+                <a:solidFill>
+                  <a:srgbClr val="FFFFFF"/>
+                </a:solidFill>
+                <a:latin typeface="Arial"/>
+              </a:defRPr>
+            </a:pPr>
+            <a:r>
+              <a:t>• Duplicate lodging: Multiple citizens file complaints for the same road hazard.</a:t>
+            </a:r>
+          </a:p>
+          <a:p>
+            <a:pPr>
+              <a:spcBef>
+                <a:spcPts val="800"/>
+              </a:spcBef>
+              <a:defRPr sz="1300">
+                <a:solidFill>
+                  <a:srgbClr val="FFFFFF"/>
+                </a:solidFill>
+                <a:latin typeface="Arial"/>
+              </a:defRPr>
+            </a:pPr>
+            <a:r>
+              <a:t>• Lack of spatial context: Ambiguous landmark descriptions delay field repair teams by days.</a:t>
             </a:r>
           </a:p>
         </p:txBody>
@@ -4958,55 +5087,55 @@
               </a:defRPr>
             </a:pPr>
             <a:r>
-              <a:t>• Zonal officers lack a centralized triage system to prioritize life-threatening electrical or road risks.</a:t>
-            </a:r>
-          </a:p>
-          <a:p>
-            <a:pPr>
-              <a:spcBef>
-                <a:spcPts val="800"/>
-              </a:spcBef>
-              <a:defRPr sz="1300">
-                <a:solidFill>
-                  <a:srgbClr val="FFFFFF"/>
-                </a:solidFill>
-                <a:latin typeface="Arial"/>
-              </a:defRPr>
-            </a:pPr>
-            <a:r>
-              <a:t>• No immutable audit trail: Complaints get deleted or marked 'resolved' without photographic verification.</a:t>
-            </a:r>
-          </a:p>
-          <a:p>
-            <a:pPr>
-              <a:spcBef>
-                <a:spcPts val="800"/>
-              </a:spcBef>
-              <a:defRPr sz="1300">
-                <a:solidFill>
-                  <a:srgbClr val="FFFFFF"/>
-                </a:solidFill>
-                <a:latin typeface="Arial"/>
-              </a:defRPr>
-            </a:pPr>
-            <a:r>
-              <a:t>• Disorganized departmental routing between BBMP (Roads), BESCOM (Power), and BWSSB (Water).</a:t>
-            </a:r>
-          </a:p>
-          <a:p>
-            <a:pPr>
-              <a:spcBef>
-                <a:spcPts val="800"/>
-              </a:spcBef>
-              <a:defRPr sz="1300">
-                <a:solidFill>
-                  <a:srgbClr val="FFFFFF"/>
-                </a:solidFill>
-                <a:latin typeface="Arial"/>
-              </a:defRPr>
-            </a:pPr>
-            <a:r>
-              <a:t>• Inability to visualize hazard clusters across ward boundaries on a live interactive GIS map.</a:t>
+              <a:t>• Municipal officers lack a centralized triage system to prioritize urgent hazards.</a:t>
+            </a:r>
+          </a:p>
+          <a:p>
+            <a:pPr>
+              <a:spcBef>
+                <a:spcPts val="800"/>
+              </a:spcBef>
+              <a:defRPr sz="1300">
+                <a:solidFill>
+                  <a:srgbClr val="FFFFFF"/>
+                </a:solidFill>
+                <a:latin typeface="Arial"/>
+              </a:defRPr>
+            </a:pPr>
+            <a:r>
+              <a:t>• No immutable audit trail: Complaints can be closed or lost without verifiable evidence.</a:t>
+            </a:r>
+          </a:p>
+          <a:p>
+            <a:pPr>
+              <a:spcBef>
+                <a:spcPts val="800"/>
+              </a:spcBef>
+              <a:defRPr sz="1300">
+                <a:solidFill>
+                  <a:srgbClr val="FFFFFF"/>
+                </a:solidFill>
+                <a:latin typeface="Arial"/>
+              </a:defRPr>
+            </a:pPr>
+            <a:r>
+              <a:t>• Departmental silos: Delayed coordination between Roads, BESCOM (Power), and Water Supply boards.</a:t>
+            </a:r>
+          </a:p>
+          <a:p>
+            <a:pPr>
+              <a:spcBef>
+                <a:spcPts val="800"/>
+              </a:spcBef>
+              <a:defRPr sz="1300">
+                <a:solidFill>
+                  <a:srgbClr val="FFFFFF"/>
+                </a:solidFill>
+                <a:latin typeface="Arial"/>
+              </a:defRPr>
+            </a:pPr>
+            <a:r>
+              <a:t>• Inability to visualize hazard clusters on an interactive spatial GIS map across city wards.</a:t>
             </a:r>
           </a:p>
         </p:txBody>
@@ -5299,23 +5428,23 @@
               </a:defRPr>
             </a:pPr>
             <a:r>
-              <a:t>• Automatic ward detection and address reverse geocoding.</a:t>
-            </a:r>
-          </a:p>
-          <a:p>
-            <a:pPr>
-              <a:spcBef>
-                <a:spcPts val="800"/>
-              </a:spcBef>
-              <a:defRPr sz="1300">
-                <a:solidFill>
-                  <a:srgbClr val="FFFFFF"/>
-                </a:solidFill>
-                <a:latin typeface="Arial"/>
-              </a:defRPr>
-            </a:pPr>
-            <a:r>
-              <a:t>• High-resolution photographic evidence upload.</a:t>
+              <a:t>• Full coverage across all 35 Tumakuru Corporation wards.</a:t>
+            </a:r>
+          </a:p>
+          <a:p>
+            <a:pPr>
+              <a:spcBef>
+                <a:spcPts val="800"/>
+              </a:spcBef>
+              <a:defRPr sz="1300">
+                <a:solidFill>
+                  <a:srgbClr val="FFFFFF"/>
+                </a:solidFill>
+                <a:latin typeface="Arial"/>
+              </a:defRPr>
+            </a:pPr>
+            <a:r>
+              <a:t>• High-resolution evidence photo upload directly to secure vault.</a:t>
             </a:r>
           </a:p>
         </p:txBody>
@@ -5412,23 +5541,23 @@
               </a:defRPr>
             </a:pPr>
             <a:r>
-              <a:t>• 100% immutable data policy: records are permanently retained.</a:t>
-            </a:r>
-          </a:p>
-          <a:p>
-            <a:pPr>
-              <a:spcBef>
-                <a:spcPts val="800"/>
-              </a:spcBef>
-              <a:defRPr sz="1300">
-                <a:solidFill>
-                  <a:srgbClr val="FFFFFF"/>
-                </a:solidFill>
-                <a:latin typeface="Arial"/>
-              </a:defRPr>
-            </a:pPr>
-            <a:r>
-              <a:t>• Write-Ahead Logging (WAL) ensures corruption-free operations.</a:t>
+              <a:t>• 100% immutable data policy: records are never lost or deleted on restart.</a:t>
+            </a:r>
+          </a:p>
+          <a:p>
+            <a:pPr>
+              <a:spcBef>
+                <a:spcPts val="800"/>
+              </a:spcBef>
+              <a:defRPr sz="1300">
+                <a:solidFill>
+                  <a:srgbClr val="FFFFFF"/>
+                </a:solidFill>
+                <a:latin typeface="Arial"/>
+              </a:defRPr>
+            </a:pPr>
+            <a:r>
+              <a:t>• Write-Ahead Logging (WAL) ensures high concurrency and reliability.</a:t>
             </a:r>
           </a:p>
           <a:p>
@@ -5573,7 +5702,7 @@
               </a:defRPr>
             </a:pPr>
             <a:r>
-              <a:t>• Real-time citizen dossier and printable case certificates.</a:t>
+              <a:t>• Public Case Tracker and printable legal complaint certificates.</a:t>
             </a:r>
           </a:p>
         </p:txBody>
@@ -5834,71 +5963,71 @@
               </a:defRPr>
             </a:pPr>
             <a:r>
-              <a:t>[CLIENT] Frontend Experience</a:t>
-            </a:r>
-          </a:p>
-          <a:p>
-            <a:pPr>
-              <a:spcBef>
-                <a:spcPts val="800"/>
-              </a:spcBef>
-              <a:defRPr sz="1300">
-                <a:solidFill>
-                  <a:srgbClr val="FFFFFF"/>
-                </a:solidFill>
-                <a:latin typeface="Arial"/>
-              </a:defRPr>
-            </a:pPr>
-            <a:r>
-              <a:t>• Pure Vanilla ES6+ Modules (Zero heavy node_modules build overhead).</a:t>
-            </a:r>
-          </a:p>
-          <a:p>
-            <a:pPr>
-              <a:spcBef>
-                <a:spcPts val="800"/>
-              </a:spcBef>
-              <a:defRPr sz="1300">
-                <a:solidFill>
-                  <a:srgbClr val="FFFFFF"/>
-                </a:solidFill>
-                <a:latin typeface="Arial"/>
-              </a:defRPr>
-            </a:pPr>
-            <a:r>
-              <a:t>• HTML5 &amp; Modern CSS3 Glassmorphism UI (Lagoon Teal / Void palette).</a:t>
-            </a:r>
-          </a:p>
-          <a:p>
-            <a:pPr>
-              <a:spcBef>
-                <a:spcPts val="800"/>
-              </a:spcBef>
-              <a:defRPr sz="1300">
-                <a:solidFill>
-                  <a:srgbClr val="FFFFFF"/>
-                </a:solidFill>
-                <a:latin typeface="Arial"/>
-              </a:defRPr>
-            </a:pPr>
-            <a:r>
-              <a:t>• Leaflet.js for high-performance municipal GIS rendering.</a:t>
-            </a:r>
-          </a:p>
-          <a:p>
-            <a:pPr>
-              <a:spcBef>
-                <a:spcPts val="800"/>
-              </a:spcBef>
-              <a:defRPr sz="1300">
-                <a:solidFill>
-                  <a:srgbClr val="FFFFFF"/>
-                </a:solidFill>
-                <a:latin typeface="Arial"/>
-              </a:defRPr>
-            </a:pPr>
-            <a:r>
-              <a:t>• HTML5 Canvas 3D Dotted Earth math engine with Fibonacci projection.</a:t>
+              <a:t>[CLIENT] Frontend Layer</a:t>
+            </a:r>
+          </a:p>
+          <a:p>
+            <a:pPr>
+              <a:spcBef>
+                <a:spcPts val="800"/>
+              </a:spcBef>
+              <a:defRPr sz="1300">
+                <a:solidFill>
+                  <a:srgbClr val="FFFFFF"/>
+                </a:solidFill>
+                <a:latin typeface="Arial"/>
+              </a:defRPr>
+            </a:pPr>
+            <a:r>
+              <a:t>• Pure Vanilla ES6+ Modules (Zero heavy build or framework overhead).</a:t>
+            </a:r>
+          </a:p>
+          <a:p>
+            <a:pPr>
+              <a:spcBef>
+                <a:spcPts val="800"/>
+              </a:spcBef>
+              <a:defRPr sz="1300">
+                <a:solidFill>
+                  <a:srgbClr val="FFFFFF"/>
+                </a:solidFill>
+                <a:latin typeface="Arial"/>
+              </a:defRPr>
+            </a:pPr>
+            <a:r>
+              <a:t>• Bespoke Glassmorphism UI (Lagoon Teal &amp; Midnight Void aesthetic).</a:t>
+            </a:r>
+          </a:p>
+          <a:p>
+            <a:pPr>
+              <a:spcBef>
+                <a:spcPts val="800"/>
+              </a:spcBef>
+              <a:defRPr sz="1300">
+                <a:solidFill>
+                  <a:srgbClr val="FFFFFF"/>
+                </a:solidFill>
+                <a:latin typeface="Arial"/>
+              </a:defRPr>
+            </a:pPr>
+            <a:r>
+              <a:t>• Leaflet.js for high-performance municipal GIS spatial explorer.</a:t>
+            </a:r>
+          </a:p>
+          <a:p>
+            <a:pPr>
+              <a:spcBef>
+                <a:spcPts val="800"/>
+              </a:spcBef>
+              <a:defRPr sz="1300">
+                <a:solidFill>
+                  <a:srgbClr val="FFFFFF"/>
+                </a:solidFill>
+                <a:latin typeface="Arial"/>
+              </a:defRPr>
+            </a:pPr>
+            <a:r>
+              <a:t>• HTML5 Canvas 3D Dotted Earth engine with Fibonacci point projection.</a:t>
             </a:r>
           </a:p>
         </p:txBody>
@@ -6188,7 +6317,7 @@
               </a:defRPr>
             </a:pPr>
             <a:r>
-              <a:t>• Ready for Firebase Authentication &amp; Firestore dual-sync.</a:t>
+              <a:t>• Permanent storage file: data/citizenshield.db</a:t>
             </a:r>
           </a:p>
         </p:txBody>
@@ -6465,55 +6594,55 @@
               </a:defRPr>
             </a:pPr>
             <a:r>
-              <a:t>• USERS Table: user_id (UUID), full_name, email, password_hash, role (citizen/officer), ward_number, created_at.</a:t>
-            </a:r>
-          </a:p>
-          <a:p>
-            <a:pPr>
-              <a:spcBef>
-                <a:spcPts val="800"/>
-              </a:spcBef>
-              <a:defRPr sz="1300">
-                <a:solidFill>
-                  <a:srgbClr val="FFFFFF"/>
-                </a:solidFill>
-                <a:latin typeface="Arial"/>
-              </a:defRPr>
-            </a:pPr>
-            <a:r>
-              <a:t>• REPORTS Table: report_id (UUID), user_id, title, category, description, priority (Urgent/Medium/Routine), status, latitude, longitude, landmark, photo_path, created_at.</a:t>
-            </a:r>
-          </a:p>
-          <a:p>
-            <a:pPr>
-              <a:spcBef>
-                <a:spcPts val="800"/>
-              </a:spcBef>
-              <a:defRPr sz="1300">
-                <a:solidFill>
-                  <a:srgbClr val="FFFFFF"/>
-                </a:solidFill>
-                <a:latin typeface="Arial"/>
-              </a:defRPr>
-            </a:pPr>
-            <a:r>
-              <a:t>• STATUS_HISTORY Table: history_id, report_id, updated_by_officer, old_status, new_status, official_remarks, updated_at.</a:t>
-            </a:r>
-          </a:p>
-          <a:p>
-            <a:pPr>
-              <a:spcBef>
-                <a:spcPts val="800"/>
-              </a:spcBef>
-              <a:defRPr sz="1300">
-                <a:solidFill>
-                  <a:srgbClr val="FFFFFF"/>
-                </a:solidFill>
-                <a:latin typeface="Arial"/>
-              </a:defRPr>
-            </a:pPr>
-            <a:r>
-              <a:t>• AUDIT_LOGS Table: log_id, action, actor_email, ip_address, timestamp.</a:t>
+              <a:t>• USERS: id, uuid, name, email, password_hash, password_salt, role (citizen/admin), department, phone, created_at.</a:t>
+            </a:r>
+          </a:p>
+          <a:p>
+            <a:pPr>
+              <a:spcBef>
+                <a:spcPts val="800"/>
+              </a:spcBef>
+              <a:defRPr sz="1300">
+                <a:solidFill>
+                  <a:srgbClr val="FFFFFF"/>
+                </a:solidFill>
+                <a:latin typeface="Arial"/>
+              </a:defRPr>
+            </a:pPr>
+            <a:r>
+              <a:t>• REPORTS: id, report_id (UUID), user_id, citizen_name, title, category, department, priority, description, location, ward, latitude, longitude, image_filename, status, admin_remarks, sla_hours, created_at, updated_at.</a:t>
+            </a:r>
+          </a:p>
+          <a:p>
+            <a:pPr>
+              <a:spcBef>
+                <a:spcPts val="800"/>
+              </a:spcBef>
+              <a:defRPr sz="1300">
+                <a:solidFill>
+                  <a:srgbClr val="FFFFFF"/>
+                </a:solidFill>
+                <a:latin typeface="Arial"/>
+              </a:defRPr>
+            </a:pPr>
+            <a:r>
+              <a:t>• STATUS_HISTORY: id, report_id, status, remarks, officer_name, officer_role, created_at.</a:t>
+            </a:r>
+          </a:p>
+          <a:p>
+            <a:pPr>
+              <a:spcBef>
+                <a:spcPts val="800"/>
+              </a:spcBef>
+              <a:defRPr sz="1300">
+                <a:solidFill>
+                  <a:srgbClr val="FFFFFF"/>
+                </a:solidFill>
+                <a:latin typeface="Arial"/>
+              </a:defRPr>
+            </a:pPr>
+            <a:r>
+              <a:t>• AUTH_TOKENS &amp; AUDIT_LOGS: Session tokens and audit logging.</a:t>
             </a:r>
           </a:p>
         </p:txBody>
@@ -6610,39 +6739,39 @@
               </a:defRPr>
             </a:pPr>
             <a:r>
-              <a:t>• No Hard Deletes: Reports and status transitions are preserved indefinitely for legal accountability.</a:t>
-            </a:r>
-          </a:p>
-          <a:p>
-            <a:pPr>
-              <a:spcBef>
-                <a:spcPts val="800"/>
-              </a:spcBef>
-              <a:defRPr sz="1300">
-                <a:solidFill>
-                  <a:srgbClr val="FFFFFF"/>
-                </a:solidFill>
-                <a:latin typeface="Arial"/>
-              </a:defRPr>
-            </a:pPr>
-            <a:r>
-              <a:t>• Strict Foreign Key Cascades: Relational integrity enforced at database engine level.</a:t>
-            </a:r>
-          </a:p>
-          <a:p>
-            <a:pPr>
-              <a:spcBef>
-                <a:spcPts val="800"/>
-              </a:spcBef>
-              <a:defRPr sz="1300">
-                <a:solidFill>
-                  <a:srgbClr val="FFFFFF"/>
-                </a:solidFill>
-                <a:latin typeface="Arial"/>
-              </a:defRPr>
-            </a:pPr>
-            <a:r>
-              <a:t>• Permanent Seeding: Pre-loaded with 6 verified municipal defects and 13 historical milestones.</a:t>
+              <a:t>• Zero Data Loss: Reports and status transitions are preserved indefinitely for administrative accountability.</a:t>
+            </a:r>
+          </a:p>
+          <a:p>
+            <a:pPr>
+              <a:spcBef>
+                <a:spcPts val="800"/>
+              </a:spcBef>
+              <a:defRPr sz="1300">
+                <a:solidFill>
+                  <a:srgbClr val="FFFFFF"/>
+                </a:solidFill>
+                <a:latin typeface="Arial"/>
+              </a:defRPr>
+            </a:pPr>
+            <a:r>
+              <a:t>• Strict Foreign Keys: Enforced relational integrity between users, reports, and history.</a:t>
+            </a:r>
+          </a:p>
+          <a:p>
+            <a:pPr>
+              <a:spcBef>
+                <a:spcPts val="800"/>
+              </a:spcBef>
+              <a:defRPr sz="1300">
+                <a:solidFill>
+                  <a:srgbClr val="FFFFFF"/>
+                </a:solidFill>
+                <a:latin typeface="Arial"/>
+              </a:defRPr>
+            </a:pPr>
+            <a:r>
+              <a:t>• Permanent Tumakuru Ward Support: All 35 corporation wards recognized in schema.</a:t>
             </a:r>
           </a:p>
           <a:p>
@@ -6757,7 +6886,7 @@
               </a:defRPr>
             </a:pPr>
             <a:r>
-              <a:t>FRONTEND INNOVATION</a:t>
+              <a:t>TUMAKURU MUNICIPAL GRID</a:t>
             </a:r>
           </a:p>
         </p:txBody>
@@ -6793,7 +6922,7 @@
               </a:defRPr>
             </a:pPr>
             <a:r>
-              <a:t>Bespoke UI Design &amp; 3D Orbital Earth Engine</a:t>
+              <a:t>Complete Tumakuru City Corporation Coverage (35 Wards)</a:t>
             </a:r>
           </a:p>
         </p:txBody>
@@ -6852,7 +6981,7 @@
         <p:spPr>
           <a:xfrm>
             <a:off x="731520" y="1645920"/>
-            <a:ext cx="5120640" cy="4572000"/>
+            <a:ext cx="3383280" cy="4572000"/>
           </a:xfrm>
           <a:prstGeom prst="roundRect">
             <a:avLst/>
@@ -6897,7 +7026,7 @@
         <p:spPr>
           <a:xfrm>
             <a:off x="914400" y="1828800"/>
-            <a:ext cx="4754880" cy="4206240"/>
+            <a:ext cx="3017520" cy="4206240"/>
           </a:xfrm>
           <a:prstGeom prst="rect">
             <a:avLst/>
@@ -6919,103 +7048,135 @@
               </a:defRPr>
             </a:pPr>
             <a:r>
-              <a:t>[3D CANVAS] 3D Dotted Earth Orbital Radar</a:t>
-            </a:r>
-          </a:p>
-          <a:p>
-            <a:pPr>
-              <a:spcBef>
-                <a:spcPts val="800"/>
-              </a:spcBef>
-              <a:defRPr sz="1300">
-                <a:solidFill>
-                  <a:srgbClr val="FFFFFF"/>
-                </a:solidFill>
-                <a:latin typeface="Arial"/>
-              </a:defRPr>
-            </a:pPr>
-            <a:r>
-              <a:t>• Custom HTML5 Canvas rendering engine without external Three.js dependencies.</a:t>
-            </a:r>
-          </a:p>
-          <a:p>
-            <a:pPr>
-              <a:spcBef>
-                <a:spcPts val="800"/>
-              </a:spcBef>
-              <a:defRPr sz="1300">
-                <a:solidFill>
-                  <a:srgbClr val="FFFFFF"/>
-                </a:solidFill>
-                <a:latin typeface="Arial"/>
-              </a:defRPr>
-            </a:pPr>
-            <a:r>
-              <a:t>• 4,200 Fibonacci stipple points calculated in spherical 3D space.</a:t>
-            </a:r>
-          </a:p>
-          <a:p>
-            <a:pPr>
-              <a:spcBef>
-                <a:spcPts val="800"/>
-              </a:spcBef>
-              <a:defRPr sz="1300">
-                <a:solidFill>
-                  <a:srgbClr val="FFFFFF"/>
-                </a:solidFill>
-                <a:latin typeface="Arial"/>
-              </a:defRPr>
-            </a:pPr>
-            <a:r>
-              <a:t>• Ray-casted continental polygons for instant planetary recognition.</a:t>
-            </a:r>
-          </a:p>
-          <a:p>
-            <a:pPr>
-              <a:spcBef>
-                <a:spcPts val="800"/>
-              </a:spcBef>
-              <a:defRPr sz="1300">
-                <a:solidFill>
-                  <a:srgbClr val="FFFFFF"/>
-                </a:solidFill>
-                <a:latin typeface="Arial"/>
-              </a:defRPr>
-            </a:pPr>
-            <a:r>
-              <a:t>• Real-time sub-satellite coordinate telemetry tracking during mouse drag.</a:t>
-            </a:r>
-          </a:p>
-          <a:p>
-            <a:pPr>
-              <a:spcBef>
-                <a:spcPts val="800"/>
-              </a:spcBef>
-              <a:defRPr sz="1300">
-                <a:solidFill>
-                  <a:srgbClr val="FFFFFF"/>
-                </a:solidFill>
-                <a:latin typeface="Arial"/>
-              </a:defRPr>
-            </a:pPr>
-            <a:r>
-              <a:t>• Animated sonar beacon rings over Bengaluru Ward 112 &amp; global municipal hubs.</a:t>
-            </a:r>
-          </a:p>
-          <a:p>
-            <a:pPr>
-              <a:spcBef>
-                <a:spcPts val="800"/>
-              </a:spcBef>
-              <a:defRPr sz="1300">
-                <a:solidFill>
-                  <a:srgbClr val="FFFFFF"/>
-                </a:solidFill>
-                <a:latin typeface="Arial"/>
-              </a:defRPr>
-            </a:pPr>
-            <a:r>
-              <a:t>• Curved 3D data telemetry arcs with travelling photon tracer particles.</a:t>
+              <a:t>[CENTRAL / NORTH] North &amp; Central Divisions</a:t>
+            </a:r>
+          </a:p>
+          <a:p>
+            <a:pPr>
+              <a:spcBef>
+                <a:spcPts val="800"/>
+              </a:spcBef>
+              <a:defRPr sz="1300">
+                <a:solidFill>
+                  <a:srgbClr val="FFFFFF"/>
+                </a:solidFill>
+                <a:latin typeface="Arial"/>
+              </a:defRPr>
+            </a:pPr>
+            <a:r>
+              <a:t>• Ward 1: Antharasanahalli / Sira Road</a:t>
+            </a:r>
+          </a:p>
+          <a:p>
+            <a:pPr>
+              <a:spcBef>
+                <a:spcPts val="800"/>
+              </a:spcBef>
+              <a:defRPr sz="1300">
+                <a:solidFill>
+                  <a:srgbClr val="FFFFFF"/>
+                </a:solidFill>
+                <a:latin typeface="Arial"/>
+              </a:defRPr>
+            </a:pPr>
+            <a:r>
+              <a:t>• Ward 2: Maralenahalli / Sira Gate</a:t>
+            </a:r>
+          </a:p>
+          <a:p>
+            <a:pPr>
+              <a:spcBef>
+                <a:spcPts val="800"/>
+              </a:spcBef>
+              <a:defRPr sz="1300">
+                <a:solidFill>
+                  <a:srgbClr val="FFFFFF"/>
+                </a:solidFill>
+                <a:latin typeface="Arial"/>
+              </a:defRPr>
+            </a:pPr>
+            <a:r>
+              <a:t>• Ward 3: Belagumba / Puttashamayyanapalya</a:t>
+            </a:r>
+          </a:p>
+          <a:p>
+            <a:pPr>
+              <a:spcBef>
+                <a:spcPts val="800"/>
+              </a:spcBef>
+              <a:defRPr sz="1300">
+                <a:solidFill>
+                  <a:srgbClr val="FFFFFF"/>
+                </a:solidFill>
+                <a:latin typeface="Arial"/>
+              </a:defRPr>
+            </a:pPr>
+            <a:r>
+              <a:t>• Ward 4: Dibbur / Temple Road</a:t>
+            </a:r>
+          </a:p>
+          <a:p>
+            <a:pPr>
+              <a:spcBef>
+                <a:spcPts val="800"/>
+              </a:spcBef>
+              <a:defRPr sz="1300">
+                <a:solidFill>
+                  <a:srgbClr val="FFFFFF"/>
+                </a:solidFill>
+                <a:latin typeface="Arial"/>
+              </a:defRPr>
+            </a:pPr>
+            <a:r>
+              <a:t>• Ward 5: Bheemasandra / Kuvempu Nagar</a:t>
+            </a:r>
+          </a:p>
+          <a:p>
+            <a:pPr>
+              <a:spcBef>
+                <a:spcPts val="800"/>
+              </a:spcBef>
+              <a:defRPr sz="1300">
+                <a:solidFill>
+                  <a:srgbClr val="FFFFFF"/>
+                </a:solidFill>
+                <a:latin typeface="Arial"/>
+              </a:defRPr>
+            </a:pPr>
+            <a:r>
+              <a:t>• Ward 11: Mandipet / Town Hall Core</a:t>
+            </a:r>
+          </a:p>
+          <a:p>
+            <a:pPr>
+              <a:spcBef>
+                <a:spcPts val="800"/>
+              </a:spcBef>
+              <a:defRPr sz="1300">
+                <a:solidFill>
+                  <a:srgbClr val="FFFFFF"/>
+                </a:solidFill>
+                <a:latin typeface="Arial"/>
+              </a:defRPr>
+            </a:pPr>
+            <a:r>
+              <a:t>• Ward 12: Chickpet / Old Market Road</a:t>
+            </a:r>
+          </a:p>
+          <a:p>
+            <a:pPr>
+              <a:spcBef>
+                <a:spcPts val="800"/>
+              </a:spcBef>
+              <a:defRPr sz="1300">
+                <a:solidFill>
+                  <a:srgbClr val="FFFFFF"/>
+                </a:solidFill>
+                <a:latin typeface="Arial"/>
+              </a:defRPr>
+            </a:pPr>
+            <a:r>
+              <a:t>• Ward 13: Ashok Nagar / MG Road</a:t>
             </a:r>
           </a:p>
         </p:txBody>
@@ -7028,8 +7189,8 @@
         </p:nvSpPr>
         <p:spPr>
           <a:xfrm>
-            <a:off x="6217920" y="1645920"/>
-            <a:ext cx="5120640" cy="4572000"/>
+            <a:off x="4389120" y="1645920"/>
+            <a:ext cx="3383280" cy="4572000"/>
           </a:xfrm>
           <a:prstGeom prst="roundRect">
             <a:avLst/>
@@ -7073,8 +7234,8 @@
         </p:nvSpPr>
         <p:spPr>
           <a:xfrm>
-            <a:off x="6400800" y="1828800"/>
-            <a:ext cx="4754880" cy="4206240"/>
+            <a:off x="4572000" y="1828800"/>
+            <a:ext cx="3017520" cy="4206240"/>
           </a:xfrm>
           <a:prstGeom prst="rect">
             <a:avLst/>
@@ -7096,87 +7257,344 @@
               </a:defRPr>
             </a:pPr>
             <a:r>
-              <a:t>[GLASSMORPHISM] Executive Glassmorphic Interface</a:t>
-            </a:r>
-          </a:p>
-          <a:p>
-            <a:pPr>
-              <a:spcBef>
-                <a:spcPts val="800"/>
-              </a:spcBef>
-              <a:defRPr sz="1300">
-                <a:solidFill>
-                  <a:srgbClr val="FFFFFF"/>
-                </a:solidFill>
-                <a:latin typeface="Arial"/>
-              </a:defRPr>
-            </a:pPr>
-            <a:r>
-              <a:t>• Bespoke non-AI visual aesthetic: Deep lagoon void (#03080c) with mint accents.</a:t>
-            </a:r>
-          </a:p>
-          <a:p>
-            <a:pPr>
-              <a:spcBef>
-                <a:spcPts val="800"/>
-              </a:spcBef>
-              <a:defRPr sz="1300">
-                <a:solidFill>
-                  <a:srgbClr val="FFFFFF"/>
-                </a:solidFill>
-                <a:latin typeface="Arial"/>
-              </a:defRPr>
-            </a:pPr>
-            <a:r>
-              <a:t>• Ultra-clear frosted glass pod with backdrop-filter: blur(28px).</a:t>
-            </a:r>
-          </a:p>
-          <a:p>
-            <a:pPr>
-              <a:spcBef>
-                <a:spcPts val="800"/>
-              </a:spcBef>
-              <a:defRPr sz="1300">
-                <a:solidFill>
-                  <a:srgbClr val="FFFFFF"/>
-                </a:solidFill>
-                <a:latin typeface="Arial"/>
-              </a:defRPr>
-            </a:pPr>
-            <a:r>
-              <a:t>• Precision HUD corner crosshairs and live orbital telemetry pills.</a:t>
-            </a:r>
-          </a:p>
-          <a:p>
-            <a:pPr>
-              <a:spcBef>
-                <a:spcPts val="800"/>
-              </a:spcBef>
-              <a:defRPr sz="1300">
-                <a:solidFill>
-                  <a:srgbClr val="FFFFFF"/>
-                </a:solidFill>
-                <a:latin typeface="Arial"/>
-              </a:defRPr>
-            </a:pPr>
-            <a:r>
-              <a:t>• Luxury Emergency Safety Ribbon with pulsing red beacon directing life-threats to Call 112.</a:t>
-            </a:r>
-          </a:p>
-          <a:p>
-            <a:pPr>
-              <a:spcBef>
-                <a:spcPts val="800"/>
-              </a:spcBef>
-              <a:defRPr sz="1300">
-                <a:solidFill>
-                  <a:srgbClr val="FFFFFF"/>
-                </a:solidFill>
-                <a:latin typeface="Arial"/>
-              </a:defRPr>
-            </a:pPr>
-            <a:r>
-              <a:t>• One-click 'Target Ward 112' auto-glide planetary camera alignment.</a:t>
+              <a:t>[URBAN CORE] Educational &amp; Residential Hubs</a:t>
+            </a:r>
+          </a:p>
+          <a:p>
+            <a:pPr>
+              <a:spcBef>
+                <a:spcPts val="800"/>
+              </a:spcBef>
+              <a:defRPr sz="1300">
+                <a:solidFill>
+                  <a:srgbClr val="FFFFFF"/>
+                </a:solidFill>
+                <a:latin typeface="Arial"/>
+              </a:defRPr>
+            </a:pPr>
+            <a:r>
+              <a:t>• Ward 10: Kyatsandra / Siddaganga Math</a:t>
+            </a:r>
+          </a:p>
+          <a:p>
+            <a:pPr>
+              <a:spcBef>
+                <a:spcPts val="800"/>
+              </a:spcBef>
+              <a:defRPr sz="1300">
+                <a:solidFill>
+                  <a:srgbClr val="FFFFFF"/>
+                </a:solidFill>
+                <a:latin typeface="Arial"/>
+              </a:defRPr>
+            </a:pPr>
+            <a:r>
+              <a:t>• Ward 16 &amp; 17: Jayanagar East / West</a:t>
+            </a:r>
+          </a:p>
+          <a:p>
+            <a:pPr>
+              <a:spcBef>
+                <a:spcPts val="800"/>
+              </a:spcBef>
+              <a:defRPr sz="1300">
+                <a:solidFill>
+                  <a:srgbClr val="FFFFFF"/>
+                </a:solidFill>
+                <a:latin typeface="Arial"/>
+              </a:defRPr>
+            </a:pPr>
+            <a:r>
+              <a:t>• Ward 18: SIT Campus / SIT Extension</a:t>
+            </a:r>
+          </a:p>
+          <a:p>
+            <a:pPr>
+              <a:spcBef>
+                <a:spcPts val="800"/>
+              </a:spcBef>
+              <a:defRPr sz="1300">
+                <a:solidFill>
+                  <a:srgbClr val="FFFFFF"/>
+                </a:solidFill>
+                <a:latin typeface="Arial"/>
+              </a:defRPr>
+            </a:pPr>
+            <a:r>
+              <a:t>• Ward 19: Vidyanagar / Siddaganga Extn</a:t>
+            </a:r>
+          </a:p>
+          <a:p>
+            <a:pPr>
+              <a:spcBef>
+                <a:spcPts val="800"/>
+              </a:spcBef>
+              <a:defRPr sz="1300">
+                <a:solidFill>
+                  <a:srgbClr val="FFFFFF"/>
+                </a:solidFill>
+                <a:latin typeface="Arial"/>
+              </a:defRPr>
+            </a:pPr>
+            <a:r>
+              <a:t>• Ward 20 &amp; 21: SS Puram (Main &amp; South)</a:t>
+            </a:r>
+          </a:p>
+          <a:p>
+            <a:pPr>
+              <a:spcBef>
+                <a:spcPts val="800"/>
+              </a:spcBef>
+              <a:defRPr sz="1300">
+                <a:solidFill>
+                  <a:srgbClr val="FFFFFF"/>
+                </a:solidFill>
+                <a:latin typeface="Arial"/>
+              </a:defRPr>
+            </a:pPr>
+            <a:r>
+              <a:t>• Ward 22: Upparhalli / Maruthi Nagar</a:t>
+            </a:r>
+          </a:p>
+          <a:p>
+            <a:pPr>
+              <a:spcBef>
+                <a:spcPts val="800"/>
+              </a:spcBef>
+              <a:defRPr sz="1300">
+                <a:solidFill>
+                  <a:srgbClr val="FFFFFF"/>
+                </a:solidFill>
+                <a:latin typeface="Arial"/>
+              </a:defRPr>
+            </a:pPr>
+            <a:r>
+              <a:t>• Ward 23: Gubbi Gate / Railway Corridor</a:t>
+            </a:r>
+          </a:p>
+          <a:p>
+            <a:pPr>
+              <a:spcBef>
+                <a:spcPts val="800"/>
+              </a:spcBef>
+              <a:defRPr sz="1300">
+                <a:solidFill>
+                  <a:srgbClr val="FFFFFF"/>
+                </a:solidFill>
+                <a:latin typeface="Arial"/>
+              </a:defRPr>
+            </a:pPr>
+            <a:r>
+              <a:t>• Ward 26: Amanikere Lake Promenade</a:t>
+            </a:r>
+          </a:p>
+        </p:txBody>
+      </p:sp>
+      <p:sp>
+        <p:nvSpPr>
+          <p:cNvPr id="10" name="Rounded Rectangle 9"/>
+          <p:cNvSpPr/>
+          <p:nvPr/>
+        </p:nvSpPr>
+        <p:spPr>
+          <a:xfrm>
+            <a:off x="8046720" y="1645920"/>
+            <a:ext cx="3383280" cy="4572000"/>
+          </a:xfrm>
+          <a:prstGeom prst="roundRect">
+            <a:avLst/>
+          </a:prstGeom>
+          <a:solidFill>
+            <a:srgbClr val="081C26"/>
+          </a:solidFill>
+          <a:ln w="12700">
+            <a:solidFill>
+              <a:srgbClr val="2DD4BF"/>
+            </a:solidFill>
+          </a:ln>
+        </p:spPr>
+        <p:style>
+          <a:lnRef idx="1">
+            <a:schemeClr val="accent1"/>
+          </a:lnRef>
+          <a:fillRef idx="3">
+            <a:schemeClr val="accent1"/>
+          </a:fillRef>
+          <a:effectRef idx="2">
+            <a:schemeClr val="accent1"/>
+          </a:effectRef>
+          <a:fontRef idx="minor">
+            <a:schemeClr val="lt1"/>
+          </a:fontRef>
+        </p:style>
+        <p:txBody>
+          <a:bodyPr rtlCol="0" anchor="ctr"/>
+          <a:lstStyle/>
+          <a:p>
+            <a:pPr algn="ctr"/>
+          </a:p>
+        </p:txBody>
+      </p:sp>
+      <p:sp>
+        <p:nvSpPr>
+          <p:cNvPr id="11" name="TextBox 10"/>
+          <p:cNvSpPr txBox="1"/>
+          <p:nvPr/>
+        </p:nvSpPr>
+        <p:spPr>
+          <a:xfrm>
+            <a:off x="8229600" y="1828800"/>
+            <a:ext cx="3017520" cy="4206240"/>
+          </a:xfrm>
+          <a:prstGeom prst="rect">
+            <a:avLst/>
+          </a:prstGeom>
+          <a:noFill/>
+        </p:spPr>
+        <p:txBody>
+          <a:bodyPr wrap="square">
+            <a:spAutoFit/>
+          </a:bodyPr>
+          <a:lstStyle/>
+          <a:p>
+            <a:pPr>
+              <a:defRPr sz="1600" b="1">
+                <a:solidFill>
+                  <a:srgbClr val="2DD4BF"/>
+                </a:solidFill>
+                <a:latin typeface="Arial"/>
+              </a:defRPr>
+            </a:pPr>
+            <a:r>
+              <a:t>[EXPANSION ZONES] Southern &amp; Industrial Rings</a:t>
+            </a:r>
+          </a:p>
+          <a:p>
+            <a:pPr>
+              <a:spcBef>
+                <a:spcPts val="800"/>
+              </a:spcBef>
+              <a:defRPr sz="1300">
+                <a:solidFill>
+                  <a:srgbClr val="FFFFFF"/>
+                </a:solidFill>
+                <a:latin typeface="Arial"/>
+              </a:defRPr>
+            </a:pPr>
+            <a:r>
+              <a:t>• Ward 7: Melekote / Sadashivanagar</a:t>
+            </a:r>
+          </a:p>
+          <a:p>
+            <a:pPr>
+              <a:spcBef>
+                <a:spcPts val="800"/>
+              </a:spcBef>
+              <a:defRPr sz="1300">
+                <a:solidFill>
+                  <a:srgbClr val="FFFFFF"/>
+                </a:solidFill>
+                <a:latin typeface="Arial"/>
+              </a:defRPr>
+            </a:pPr>
+            <a:r>
+              <a:t>• Ward 8 &amp; 9: Batawadi North &amp; South</a:t>
+            </a:r>
+          </a:p>
+          <a:p>
+            <a:pPr>
+              <a:spcBef>
+                <a:spcPts val="800"/>
+              </a:spcBef>
+              <a:defRPr sz="1300">
+                <a:solidFill>
+                  <a:srgbClr val="FFFFFF"/>
+                </a:solidFill>
+                <a:latin typeface="Arial"/>
+              </a:defRPr>
+            </a:pPr>
+            <a:r>
+              <a:t>• Ward 14: Gandhi Nagar / CSI Layout</a:t>
+            </a:r>
+          </a:p>
+          <a:p>
+            <a:pPr>
+              <a:spcBef>
+                <a:spcPts val="800"/>
+              </a:spcBef>
+              <a:defRPr sz="1300">
+                <a:solidFill>
+                  <a:srgbClr val="FFFFFF"/>
+                </a:solidFill>
+                <a:latin typeface="Arial"/>
+              </a:defRPr>
+            </a:pPr>
+            <a:r>
+              <a:t>• Ward 29: Gokula Extension</a:t>
+            </a:r>
+          </a:p>
+          <a:p>
+            <a:pPr>
+              <a:spcBef>
+                <a:spcPts val="800"/>
+              </a:spcBef>
+              <a:defRPr sz="1300">
+                <a:solidFill>
+                  <a:srgbClr val="FFFFFF"/>
+                </a:solidFill>
+                <a:latin typeface="Arial"/>
+              </a:defRPr>
+            </a:pPr>
+            <a:r>
+              <a:t>• Ward 30: Sathyamangala Industrial Bypass</a:t>
+            </a:r>
+          </a:p>
+          <a:p>
+            <a:pPr>
+              <a:spcBef>
+                <a:spcPts val="800"/>
+              </a:spcBef>
+              <a:defRPr sz="1300">
+                <a:solidFill>
+                  <a:srgbClr val="FFFFFF"/>
+                </a:solidFill>
+                <a:latin typeface="Arial"/>
+              </a:defRPr>
+            </a:pPr>
+            <a:r>
+              <a:t>• Ward 31: Shettihalli Ring Road</a:t>
+            </a:r>
+          </a:p>
+          <a:p>
+            <a:pPr>
+              <a:spcBef>
+                <a:spcPts val="800"/>
+              </a:spcBef>
+              <a:defRPr sz="1300">
+                <a:solidFill>
+                  <a:srgbClr val="FFFFFF"/>
+                </a:solidFill>
+                <a:latin typeface="Arial"/>
+              </a:defRPr>
+            </a:pPr>
+            <a:r>
+              <a:t>• Ward 32: Devarayapatna / Kunigal Road</a:t>
+            </a:r>
+          </a:p>
+          <a:p>
+            <a:pPr>
+              <a:spcBef>
+                <a:spcPts val="800"/>
+              </a:spcBef>
+              <a:defRPr sz="1300">
+                <a:solidFill>
+                  <a:srgbClr val="FFFFFF"/>
+                </a:solidFill>
+                <a:latin typeface="Arial"/>
+              </a:defRPr>
+            </a:pPr>
+            <a:r>
+              <a:t>• Ward 35: Obalapura Ring Road Junction</a:t>
             </a:r>
           </a:p>
         </p:txBody>
@@ -7275,7 +7693,7 @@
               </a:defRPr>
             </a:pPr>
             <a:r>
-              <a:t>OPERATIONAL WORKFLOW</a:t>
+              <a:t>FRONTEND INNOVATION</a:t>
             </a:r>
           </a:p>
         </p:txBody>
@@ -7311,7 +7729,7 @@
               </a:defRPr>
             </a:pPr>
             <a:r>
-              <a:t>End-to-End Civic Grievance Lifecycle</a:t>
+              <a:t>Bespoke UI Design &amp; 3D Orbital Earth Engine</a:t>
             </a:r>
           </a:p>
         </p:txBody>
@@ -7370,7 +7788,7 @@
         <p:spPr>
           <a:xfrm>
             <a:off x="731520" y="1645920"/>
-            <a:ext cx="2468880" cy="4572000"/>
+            <a:ext cx="5120640" cy="4572000"/>
           </a:xfrm>
           <a:prstGeom prst="roundRect">
             <a:avLst/>
@@ -7415,7 +7833,7 @@
         <p:spPr>
           <a:xfrm>
             <a:off x="914400" y="1828800"/>
-            <a:ext cx="2103120" cy="4206240"/>
+            <a:ext cx="4754880" cy="4206240"/>
           </a:xfrm>
           <a:prstGeom prst="rect">
             <a:avLst/>
@@ -7437,55 +7855,103 @@
               </a:defRPr>
             </a:pPr>
             <a:r>
-              <a:t>[CITIZEN] Step 1: Lodge</a:t>
-            </a:r>
-          </a:p>
-          <a:p>
-            <a:pPr>
-              <a:spcBef>
-                <a:spcPts val="800"/>
-              </a:spcBef>
-              <a:defRPr sz="1300">
-                <a:solidFill>
-                  <a:srgbClr val="FFFFFF"/>
-                </a:solidFill>
-                <a:latin typeface="Arial"/>
-              </a:defRPr>
-            </a:pPr>
-            <a:r>
-              <a:t>• Citizen captures photo &amp; pins GPS on interactive map.</a:t>
-            </a:r>
-          </a:p>
-          <a:p>
-            <a:pPr>
-              <a:spcBef>
-                <a:spcPts val="800"/>
-              </a:spcBef>
-              <a:defRPr sz="1300">
-                <a:solidFill>
-                  <a:srgbClr val="FFFFFF"/>
-                </a:solidFill>
-                <a:latin typeface="Arial"/>
-              </a:defRPr>
-            </a:pPr>
-            <a:r>
-              <a:t>• Selects category: Roads, Lighting, Water, Sanitation.</a:t>
-            </a:r>
-          </a:p>
-          <a:p>
-            <a:pPr>
-              <a:spcBef>
-                <a:spcPts val="800"/>
-              </a:spcBef>
-              <a:defRPr sz="1300">
-                <a:solidFill>
-                  <a:srgbClr val="FFFFFF"/>
-                </a:solidFill>
-                <a:latin typeface="Arial"/>
-              </a:defRPr>
-            </a:pPr>
-            <a:r>
-              <a:t>• Instant unique tracking ID generated.</a:t>
+              <a:t>[3D CANVAS] 3D Dotted Earth Orbital Radar</a:t>
+            </a:r>
+          </a:p>
+          <a:p>
+            <a:pPr>
+              <a:spcBef>
+                <a:spcPts val="800"/>
+              </a:spcBef>
+              <a:defRPr sz="1300">
+                <a:solidFill>
+                  <a:srgbClr val="FFFFFF"/>
+                </a:solidFill>
+                <a:latin typeface="Arial"/>
+              </a:defRPr>
+            </a:pPr>
+            <a:r>
+              <a:t>• Custom HTML5 Canvas rendering engine without external Three.js bloat.</a:t>
+            </a:r>
+          </a:p>
+          <a:p>
+            <a:pPr>
+              <a:spcBef>
+                <a:spcPts val="800"/>
+              </a:spcBef>
+              <a:defRPr sz="1300">
+                <a:solidFill>
+                  <a:srgbClr val="FFFFFF"/>
+                </a:solidFill>
+                <a:latin typeface="Arial"/>
+              </a:defRPr>
+            </a:pPr>
+            <a:r>
+              <a:t>• 4,200 Fibonacci stipple points calculated in spherical 3D space.</a:t>
+            </a:r>
+          </a:p>
+          <a:p>
+            <a:pPr>
+              <a:spcBef>
+                <a:spcPts val="800"/>
+              </a:spcBef>
+              <a:defRPr sz="1300">
+                <a:solidFill>
+                  <a:srgbClr val="FFFFFF"/>
+                </a:solidFill>
+                <a:latin typeface="Arial"/>
+              </a:defRPr>
+            </a:pPr>
+            <a:r>
+              <a:t>• Spherical ray-casted continental boundaries for realistic planetary geography.</a:t>
+            </a:r>
+          </a:p>
+          <a:p>
+            <a:pPr>
+              <a:spcBef>
+                <a:spcPts val="800"/>
+              </a:spcBef>
+              <a:defRPr sz="1300">
+                <a:solidFill>
+                  <a:srgbClr val="FFFFFF"/>
+                </a:solidFill>
+                <a:latin typeface="Arial"/>
+              </a:defRPr>
+            </a:pPr>
+            <a:r>
+              <a:t>• Real-time sub-satellite coordinate telemetry tracking during mouse drag.</a:t>
+            </a:r>
+          </a:p>
+          <a:p>
+            <a:pPr>
+              <a:spcBef>
+                <a:spcPts val="800"/>
+              </a:spcBef>
+              <a:defRPr sz="1300">
+                <a:solidFill>
+                  <a:srgbClr val="FFFFFF"/>
+                </a:solidFill>
+                <a:latin typeface="Arial"/>
+              </a:defRPr>
+            </a:pPr>
+            <a:r>
+              <a:t>• Animated sonar beacon ring focused on Tumakuru (13.3414° N, 77.1022° E).</a:t>
+            </a:r>
+          </a:p>
+          <a:p>
+            <a:pPr>
+              <a:spcBef>
+                <a:spcPts val="800"/>
+              </a:spcBef>
+              <a:defRPr sz="1300">
+                <a:solidFill>
+                  <a:srgbClr val="FFFFFF"/>
+                </a:solidFill>
+                <a:latin typeface="Arial"/>
+              </a:defRPr>
+            </a:pPr>
+            <a:r>
+              <a:t>• 1-Click 'Target Tumakuru' auto-glide camera alignment button.</a:t>
             </a:r>
           </a:p>
         </p:txBody>
@@ -7498,8 +7964,8 @@
         </p:nvSpPr>
         <p:spPr>
           <a:xfrm>
-            <a:off x="3474720" y="1645920"/>
-            <a:ext cx="2468880" cy="4572000"/>
+            <a:off x="6217920" y="1645920"/>
+            <a:ext cx="5120640" cy="4572000"/>
           </a:xfrm>
           <a:prstGeom prst="roundRect">
             <a:avLst/>
@@ -7543,8 +8009,8 @@
         </p:nvSpPr>
         <p:spPr>
           <a:xfrm>
-            <a:off x="3657600" y="1828800"/>
-            <a:ext cx="2103120" cy="4206240"/>
+            <a:off x="6400800" y="1828800"/>
+            <a:ext cx="4754880" cy="4206240"/>
           </a:xfrm>
           <a:prstGeom prst="rect">
             <a:avLst/>
@@ -7566,313 +8032,87 @@
               </a:defRPr>
             </a:pPr>
             <a:r>
-              <a:t>[DISPATCH] Step 2: Triage</a:t>
-            </a:r>
-          </a:p>
-          <a:p>
-            <a:pPr>
-              <a:spcBef>
-                <a:spcPts val="800"/>
-              </a:spcBef>
-              <a:defRPr sz="1300">
-                <a:solidFill>
-                  <a:srgbClr val="FFFFFF"/>
-                </a:solidFill>
-                <a:latin typeface="Arial"/>
-              </a:defRPr>
-            </a:pPr>
-            <a:r>
-              <a:t>• Officer views incoming report on GIS Radar.</a:t>
-            </a:r>
-          </a:p>
-          <a:p>
-            <a:pPr>
-              <a:spcBef>
-                <a:spcPts val="800"/>
-              </a:spcBef>
-              <a:defRPr sz="1300">
-                <a:solidFill>
-                  <a:srgbClr val="FFFFFF"/>
-                </a:solidFill>
-                <a:latin typeface="Arial"/>
-              </a:defRPr>
-            </a:pPr>
-            <a:r>
-              <a:t>• Urgent hazards highlighted with glowing amber/red pins.</a:t>
-            </a:r>
-          </a:p>
-          <a:p>
-            <a:pPr>
-              <a:spcBef>
-                <a:spcPts val="800"/>
-              </a:spcBef>
-              <a:defRPr sz="1300">
-                <a:solidFill>
-                  <a:srgbClr val="FFFFFF"/>
-                </a:solidFill>
-                <a:latin typeface="Arial"/>
-              </a:defRPr>
-            </a:pPr>
-            <a:r>
-              <a:t>• Dispatched to departmental contractor.</a:t>
-            </a:r>
-          </a:p>
-        </p:txBody>
-      </p:sp>
-      <p:sp>
-        <p:nvSpPr>
-          <p:cNvPr id="10" name="Rounded Rectangle 9"/>
-          <p:cNvSpPr/>
-          <p:nvPr/>
-        </p:nvSpPr>
-        <p:spPr>
-          <a:xfrm>
-            <a:off x="6217920" y="1645920"/>
-            <a:ext cx="2468880" cy="4572000"/>
-          </a:xfrm>
-          <a:prstGeom prst="roundRect">
-            <a:avLst/>
-          </a:prstGeom>
-          <a:solidFill>
-            <a:srgbClr val="081C26"/>
-          </a:solidFill>
-          <a:ln w="12700">
-            <a:solidFill>
-              <a:srgbClr val="2DD4BF"/>
-            </a:solidFill>
-          </a:ln>
-        </p:spPr>
-        <p:style>
-          <a:lnRef idx="1">
-            <a:schemeClr val="accent1"/>
-          </a:lnRef>
-          <a:fillRef idx="3">
-            <a:schemeClr val="accent1"/>
-          </a:fillRef>
-          <a:effectRef idx="2">
-            <a:schemeClr val="accent1"/>
-          </a:effectRef>
-          <a:fontRef idx="minor">
-            <a:schemeClr val="lt1"/>
-          </a:fontRef>
-        </p:style>
-        <p:txBody>
-          <a:bodyPr rtlCol="0" anchor="ctr"/>
-          <a:lstStyle/>
-          <a:p>
-            <a:pPr algn="ctr"/>
-          </a:p>
-        </p:txBody>
-      </p:sp>
-      <p:sp>
-        <p:nvSpPr>
-          <p:cNvPr id="11" name="TextBox 10"/>
-          <p:cNvSpPr txBox="1"/>
-          <p:nvPr/>
-        </p:nvSpPr>
-        <p:spPr>
-          <a:xfrm>
-            <a:off x="6400800" y="1828800"/>
-            <a:ext cx="2103120" cy="4206240"/>
-          </a:xfrm>
-          <a:prstGeom prst="rect">
-            <a:avLst/>
-          </a:prstGeom>
-          <a:noFill/>
-        </p:spPr>
-        <p:txBody>
-          <a:bodyPr wrap="square">
-            <a:spAutoFit/>
-          </a:bodyPr>
-          <a:lstStyle/>
-          <a:p>
-            <a:pPr>
-              <a:defRPr sz="1600" b="1">
-                <a:solidFill>
-                  <a:srgbClr val="2DD4BF"/>
-                </a:solidFill>
-                <a:latin typeface="Arial"/>
-              </a:defRPr>
-            </a:pPr>
-            <a:r>
-              <a:t>[FIELD] Step 3: Rectify</a:t>
-            </a:r>
-          </a:p>
-          <a:p>
-            <a:pPr>
-              <a:spcBef>
-                <a:spcPts val="800"/>
-              </a:spcBef>
-              <a:defRPr sz="1300">
-                <a:solidFill>
-                  <a:srgbClr val="FFFFFF"/>
-                </a:solidFill>
-                <a:latin typeface="Arial"/>
-              </a:defRPr>
-            </a:pPr>
-            <a:r>
-              <a:t>• Field engineers complete physical road/grid repairs.</a:t>
-            </a:r>
-          </a:p>
-          <a:p>
-            <a:pPr>
-              <a:spcBef>
-                <a:spcPts val="800"/>
-              </a:spcBef>
-              <a:defRPr sz="1300">
-                <a:solidFill>
-                  <a:srgbClr val="FFFFFF"/>
-                </a:solidFill>
-                <a:latin typeface="Arial"/>
-              </a:defRPr>
-            </a:pPr>
-            <a:r>
-              <a:t>• Status moved from 'Inspection' to 'Resolved'.</a:t>
-            </a:r>
-          </a:p>
-          <a:p>
-            <a:pPr>
-              <a:spcBef>
-                <a:spcPts val="800"/>
-              </a:spcBef>
-              <a:defRPr sz="1300">
-                <a:solidFill>
-                  <a:srgbClr val="FFFFFF"/>
-                </a:solidFill>
-                <a:latin typeface="Arial"/>
-              </a:defRPr>
-            </a:pPr>
-            <a:r>
-              <a:t>• Official remarks logged into SQLite vault.</a:t>
-            </a:r>
-          </a:p>
-        </p:txBody>
-      </p:sp>
-      <p:sp>
-        <p:nvSpPr>
-          <p:cNvPr id="12" name="Rounded Rectangle 11"/>
-          <p:cNvSpPr/>
-          <p:nvPr/>
-        </p:nvSpPr>
-        <p:spPr>
-          <a:xfrm>
-            <a:off x="8961120" y="1645920"/>
-            <a:ext cx="2468880" cy="4572000"/>
-          </a:xfrm>
-          <a:prstGeom prst="roundRect">
-            <a:avLst/>
-          </a:prstGeom>
-          <a:solidFill>
-            <a:srgbClr val="081C26"/>
-          </a:solidFill>
-          <a:ln w="12700">
-            <a:solidFill>
-              <a:srgbClr val="2DD4BF"/>
-            </a:solidFill>
-          </a:ln>
-        </p:spPr>
-        <p:style>
-          <a:lnRef idx="1">
-            <a:schemeClr val="accent1"/>
-          </a:lnRef>
-          <a:fillRef idx="3">
-            <a:schemeClr val="accent1"/>
-          </a:fillRef>
-          <a:effectRef idx="2">
-            <a:schemeClr val="accent1"/>
-          </a:effectRef>
-          <a:fontRef idx="minor">
-            <a:schemeClr val="lt1"/>
-          </a:fontRef>
-        </p:style>
-        <p:txBody>
-          <a:bodyPr rtlCol="0" anchor="ctr"/>
-          <a:lstStyle/>
-          <a:p>
-            <a:pPr algn="ctr"/>
-          </a:p>
-        </p:txBody>
-      </p:sp>
-      <p:sp>
-        <p:nvSpPr>
-          <p:cNvPr id="13" name="TextBox 12"/>
-          <p:cNvSpPr txBox="1"/>
-          <p:nvPr/>
-        </p:nvSpPr>
-        <p:spPr>
-          <a:xfrm>
-            <a:off x="9144000" y="1828800"/>
-            <a:ext cx="2103120" cy="4206240"/>
-          </a:xfrm>
-          <a:prstGeom prst="rect">
-            <a:avLst/>
-          </a:prstGeom>
-          <a:noFill/>
-        </p:spPr>
-        <p:txBody>
-          <a:bodyPr wrap="square">
-            <a:spAutoFit/>
-          </a:bodyPr>
-          <a:lstStyle/>
-          <a:p>
-            <a:pPr>
-              <a:defRPr sz="1600" b="1">
-                <a:solidFill>
-                  <a:srgbClr val="2DD4BF"/>
-                </a:solidFill>
-                <a:latin typeface="Arial"/>
-              </a:defRPr>
-            </a:pPr>
-            <a:r>
-              <a:t>[CERTIFICATE] Step 4: Certify</a:t>
-            </a:r>
-          </a:p>
-          <a:p>
-            <a:pPr>
-              <a:spcBef>
-                <a:spcPts val="800"/>
-              </a:spcBef>
-              <a:defRPr sz="1300">
-                <a:solidFill>
-                  <a:srgbClr val="FFFFFF"/>
-                </a:solidFill>
-                <a:latin typeface="Arial"/>
-              </a:defRPr>
-            </a:pPr>
-            <a:r>
-              <a:t>• Citizen receives updated status dossier.</a:t>
-            </a:r>
-          </a:p>
-          <a:p>
-            <a:pPr>
-              <a:spcBef>
-                <a:spcPts val="800"/>
-              </a:spcBef>
-              <a:defRPr sz="1300">
-                <a:solidFill>
-                  <a:srgbClr val="FFFFFF"/>
-                </a:solidFill>
-                <a:latin typeface="Arial"/>
-              </a:defRPr>
-            </a:pPr>
-            <a:r>
-              <a:t>• Printable Legal Case Certificate generated.</a:t>
-            </a:r>
-          </a:p>
-          <a:p>
-            <a:pPr>
-              <a:spcBef>
-                <a:spcPts val="800"/>
-              </a:spcBef>
-              <a:defRPr sz="1300">
-                <a:solidFill>
-                  <a:srgbClr val="FFFFFF"/>
-                </a:solidFill>
-                <a:latin typeface="Arial"/>
-              </a:defRPr>
-            </a:pPr>
-            <a:r>
-              <a:t>• Complete audit trail signed &amp; locked.</a:t>
+              <a:t>[GLASSMORPHISM] Executive Glassmorphic Interface</a:t>
+            </a:r>
+          </a:p>
+          <a:p>
+            <a:pPr>
+              <a:spcBef>
+                <a:spcPts val="800"/>
+              </a:spcBef>
+              <a:defRPr sz="1300">
+                <a:solidFill>
+                  <a:srgbClr val="FFFFFF"/>
+                </a:solidFill>
+                <a:latin typeface="Arial"/>
+              </a:defRPr>
+            </a:pPr>
+            <a:r>
+              <a:t>• Bespoke non-generic visual aesthetic: Deep lagoon void (#03080c) with mint accents.</a:t>
+            </a:r>
+          </a:p>
+          <a:p>
+            <a:pPr>
+              <a:spcBef>
+                <a:spcPts val="800"/>
+              </a:spcBef>
+              <a:defRPr sz="1300">
+                <a:solidFill>
+                  <a:srgbClr val="FFFFFF"/>
+                </a:solidFill>
+                <a:latin typeface="Arial"/>
+              </a:defRPr>
+            </a:pPr>
+            <a:r>
+              <a:t>• Ultra-clear frosted glass pod with backdrop-filter: blur(28px).</a:t>
+            </a:r>
+          </a:p>
+          <a:p>
+            <a:pPr>
+              <a:spcBef>
+                <a:spcPts val="800"/>
+              </a:spcBef>
+              <a:defRPr sz="1300">
+                <a:solidFill>
+                  <a:srgbClr val="FFFFFF"/>
+                </a:solidFill>
+                <a:latin typeface="Arial"/>
+              </a:defRPr>
+            </a:pPr>
+            <a:r>
+              <a:t>• Precision HUD corner crosshairs and live orbital telemetry badges.</a:t>
+            </a:r>
+          </a:p>
+          <a:p>
+            <a:pPr>
+              <a:spcBef>
+                <a:spcPts val="800"/>
+              </a:spcBef>
+              <a:defRPr sz="1300">
+                <a:solidFill>
+                  <a:srgbClr val="FFFFFF"/>
+                </a:solidFill>
+                <a:latin typeface="Arial"/>
+              </a:defRPr>
+            </a:pPr>
+            <a:r>
+              <a:t>• Executive Emergency Safety Ribbon with pulsing red beacon directing crime/fire to 112.</a:t>
+            </a:r>
+          </a:p>
+          <a:p>
+            <a:pPr>
+              <a:spcBef>
+                <a:spcPts val="800"/>
+              </a:spcBef>
+              <a:defRPr sz="1300">
+                <a:solidFill>
+                  <a:srgbClr val="FFFFFF"/>
+                </a:solidFill>
+                <a:latin typeface="Arial"/>
+              </a:defRPr>
+            </a:pPr>
+            <a:r>
+              <a:t>• Fully responsive layout across mobile, tablet, and widescreen monitors.</a:t>
             </a:r>
           </a:p>
         </p:txBody>
@@ -7971,7 +8211,7 @@
               </a:defRPr>
             </a:pPr>
             <a:r>
-              <a:t>SYSTEM SECURITY</a:t>
+              <a:t>OPERATIONAL WORKFLOW</a:t>
             </a:r>
           </a:p>
         </p:txBody>
@@ -8007,7 +8247,7 @@
               </a:defRPr>
             </a:pPr>
             <a:r>
-              <a:t>Security Architecture &amp; Privacy Safeguards</a:t>
+              <a:t>End-to-End Civic Grievance Lifecycle</a:t>
             </a:r>
           </a:p>
         </p:txBody>
@@ -8066,7 +8306,7 @@
         <p:spPr>
           <a:xfrm>
             <a:off x="731520" y="1645920"/>
-            <a:ext cx="5120640" cy="4572000"/>
+            <a:ext cx="2468880" cy="4572000"/>
           </a:xfrm>
           <a:prstGeom prst="roundRect">
             <a:avLst/>
@@ -8111,7 +8351,7 @@
         <p:spPr>
           <a:xfrm>
             <a:off x="914400" y="1828800"/>
-            <a:ext cx="4754880" cy="4206240"/>
+            <a:ext cx="2103120" cy="4206240"/>
           </a:xfrm>
           <a:prstGeom prst="rect">
             <a:avLst/>
@@ -8133,71 +8373,55 @@
               </a:defRPr>
             </a:pPr>
             <a:r>
-              <a:t>[AUTHENTICATION] Authentication &amp; Access Control</a:t>
-            </a:r>
-          </a:p>
-          <a:p>
-            <a:pPr>
-              <a:spcBef>
-                <a:spcPts val="800"/>
-              </a:spcBef>
-              <a:defRPr sz="1300">
-                <a:solidFill>
-                  <a:srgbClr val="FFFFFF"/>
-                </a:solidFill>
-                <a:latin typeface="Arial"/>
-              </a:defRPr>
-            </a:pPr>
-            <a:r>
-              <a:t>• Role-Based Access Control (RBAC): Strict separation between Citizen and Municipal Officer roles.</a:t>
-            </a:r>
-          </a:p>
-          <a:p>
-            <a:pPr>
-              <a:spcBef>
-                <a:spcPts val="800"/>
-              </a:spcBef>
-              <a:defRPr sz="1300">
-                <a:solidFill>
-                  <a:srgbClr val="FFFFFF"/>
-                </a:solidFill>
-                <a:latin typeface="Arial"/>
-              </a:defRPr>
-            </a:pPr>
-            <a:r>
-              <a:t>• Protected Officer Endpoints: Only verified staff can update complaint statuses or view full departmental logs.</a:t>
-            </a:r>
-          </a:p>
-          <a:p>
-            <a:pPr>
-              <a:spcBef>
-                <a:spcPts val="800"/>
-              </a:spcBef>
-              <a:defRPr sz="1300">
-                <a:solidFill>
-                  <a:srgbClr val="FFFFFF"/>
-                </a:solidFill>
-                <a:latin typeface="Arial"/>
-              </a:defRPr>
-            </a:pPr>
-            <a:r>
-              <a:t>• Secure Token Authentication: 64-character cryptographic hexadecimal bearer tokens.</a:t>
-            </a:r>
-          </a:p>
-          <a:p>
-            <a:pPr>
-              <a:spcBef>
-                <a:spcPts val="800"/>
-              </a:spcBef>
-              <a:defRPr sz="1300">
-                <a:solidFill>
-                  <a:srgbClr val="FFFFFF"/>
-                </a:solidFill>
-                <a:latin typeface="Arial"/>
-              </a:defRPr>
-            </a:pPr>
-            <a:r>
-              <a:t>• Password Hashing: SHA-256 / PBKDF2 with unique cryptographic salt per user.</a:t>
+              <a:t>[CITIZEN] Step 1: Lodge</a:t>
+            </a:r>
+          </a:p>
+          <a:p>
+            <a:pPr>
+              <a:spcBef>
+                <a:spcPts val="800"/>
+              </a:spcBef>
+              <a:defRPr sz="1300">
+                <a:solidFill>
+                  <a:srgbClr val="FFFFFF"/>
+                </a:solidFill>
+                <a:latin typeface="Arial"/>
+              </a:defRPr>
+            </a:pPr>
+            <a:r>
+              <a:t>• Citizen captures photo &amp; pins GPS on interactive map.</a:t>
+            </a:r>
+          </a:p>
+          <a:p>
+            <a:pPr>
+              <a:spcBef>
+                <a:spcPts val="800"/>
+              </a:spcBef>
+              <a:defRPr sz="1300">
+                <a:solidFill>
+                  <a:srgbClr val="FFFFFF"/>
+                </a:solidFill>
+                <a:latin typeface="Arial"/>
+              </a:defRPr>
+            </a:pPr>
+            <a:r>
+              <a:t>• Selects from 35 Tumakuru Wards &amp; category.</a:t>
+            </a:r>
+          </a:p>
+          <a:p>
+            <a:pPr>
+              <a:spcBef>
+                <a:spcPts val="800"/>
+              </a:spcBef>
+              <a:defRPr sz="1300">
+                <a:solidFill>
+                  <a:srgbClr val="FFFFFF"/>
+                </a:solidFill>
+                <a:latin typeface="Arial"/>
+              </a:defRPr>
+            </a:pPr>
+            <a:r>
+              <a:t>• Instant unique tracking ID generated.</a:t>
             </a:r>
           </a:p>
         </p:txBody>
@@ -8210,8 +8434,8 @@
         </p:nvSpPr>
         <p:spPr>
           <a:xfrm>
-            <a:off x="6217920" y="1645920"/>
-            <a:ext cx="5120640" cy="4572000"/>
+            <a:off x="3474720" y="1645920"/>
+            <a:ext cx="2468880" cy="4572000"/>
           </a:xfrm>
           <a:prstGeom prst="roundRect">
             <a:avLst/>
@@ -8255,8 +8479,8 @@
         </p:nvSpPr>
         <p:spPr>
           <a:xfrm>
-            <a:off x="6400800" y="1828800"/>
-            <a:ext cx="4754880" cy="4206240"/>
+            <a:off x="3657600" y="1828800"/>
+            <a:ext cx="2103120" cy="4206240"/>
           </a:xfrm>
           <a:prstGeom prst="rect">
             <a:avLst/>
@@ -8278,71 +8502,313 @@
               </a:defRPr>
             </a:pPr>
             <a:r>
-              <a:t>[COMPLIANCE] Privacy &amp; Civic Safety Safeguards</a:t>
-            </a:r>
-          </a:p>
-          <a:p>
-            <a:pPr>
-              <a:spcBef>
-                <a:spcPts val="800"/>
-              </a:spcBef>
-              <a:defRPr sz="1300">
-                <a:solidFill>
-                  <a:srgbClr val="FFFFFF"/>
-                </a:solidFill>
-                <a:latin typeface="Arial"/>
-              </a:defRPr>
-            </a:pPr>
-            <a:r>
-              <a:t>• Consent-Based Geolocation: GPS coordinates are collected only upon explicit browser permission.</a:t>
-            </a:r>
-          </a:p>
-          <a:p>
-            <a:pPr>
-              <a:spcBef>
-                <a:spcPts val="800"/>
-              </a:spcBef>
-              <a:defRPr sz="1300">
-                <a:solidFill>
-                  <a:srgbClr val="FFFFFF"/>
-                </a:solidFill>
-                <a:latin typeface="Arial"/>
-              </a:defRPr>
-            </a:pPr>
-            <a:r>
-              <a:t>• Executive Emergency Shielding: Clear non-emergency directives preventing civic tool misuse during life threats (direct 112 routing).</a:t>
-            </a:r>
-          </a:p>
-          <a:p>
-            <a:pPr>
-              <a:spcBef>
-                <a:spcPts val="800"/>
-              </a:spcBef>
-              <a:defRPr sz="1300">
-                <a:solidFill>
-                  <a:srgbClr val="FFFFFF"/>
-                </a:solidFill>
-                <a:latin typeface="Arial"/>
-              </a:defRPr>
-            </a:pPr>
-            <a:r>
-              <a:t>• File Upload Protection: Strict filetype verification (JPEG, PNG, WebP) with sanitized randomized filenames.</a:t>
-            </a:r>
-          </a:p>
-          <a:p>
-            <a:pPr>
-              <a:spcBef>
-                <a:spcPts val="800"/>
-              </a:spcBef>
-              <a:defRPr sz="1300">
-                <a:solidFill>
-                  <a:srgbClr val="FFFFFF"/>
-                </a:solidFill>
-                <a:latin typeface="Arial"/>
-              </a:defRPr>
-            </a:pPr>
-            <a:r>
-              <a:t>• Cross-Origin &amp; Injection Guard: Parameterized SQL queries preventing SQL Injection entirely.</a:t>
+              <a:t>[DISPATCH] Step 2: Triage</a:t>
+            </a:r>
+          </a:p>
+          <a:p>
+            <a:pPr>
+              <a:spcBef>
+                <a:spcPts val="800"/>
+              </a:spcBef>
+              <a:defRPr sz="1300">
+                <a:solidFill>
+                  <a:srgbClr val="FFFFFF"/>
+                </a:solidFill>
+                <a:latin typeface="Arial"/>
+              </a:defRPr>
+            </a:pPr>
+            <a:r>
+              <a:t>• Officer views incoming report on GIS Radar.</a:t>
+            </a:r>
+          </a:p>
+          <a:p>
+            <a:pPr>
+              <a:spcBef>
+                <a:spcPts val="800"/>
+              </a:spcBef>
+              <a:defRPr sz="1300">
+                <a:solidFill>
+                  <a:srgbClr val="FFFFFF"/>
+                </a:solidFill>
+                <a:latin typeface="Arial"/>
+              </a:defRPr>
+            </a:pPr>
+            <a:r>
+              <a:t>• Urgent hazards highlighted with glowing amber/red pins.</a:t>
+            </a:r>
+          </a:p>
+          <a:p>
+            <a:pPr>
+              <a:spcBef>
+                <a:spcPts val="800"/>
+              </a:spcBef>
+              <a:defRPr sz="1300">
+                <a:solidFill>
+                  <a:srgbClr val="FFFFFF"/>
+                </a:solidFill>
+                <a:latin typeface="Arial"/>
+              </a:defRPr>
+            </a:pPr>
+            <a:r>
+              <a:t>• Dispatched to departmental contractor.</a:t>
+            </a:r>
+          </a:p>
+        </p:txBody>
+      </p:sp>
+      <p:sp>
+        <p:nvSpPr>
+          <p:cNvPr id="10" name="Rounded Rectangle 9"/>
+          <p:cNvSpPr/>
+          <p:nvPr/>
+        </p:nvSpPr>
+        <p:spPr>
+          <a:xfrm>
+            <a:off x="6217920" y="1645920"/>
+            <a:ext cx="2468880" cy="4572000"/>
+          </a:xfrm>
+          <a:prstGeom prst="roundRect">
+            <a:avLst/>
+          </a:prstGeom>
+          <a:solidFill>
+            <a:srgbClr val="081C26"/>
+          </a:solidFill>
+          <a:ln w="12700">
+            <a:solidFill>
+              <a:srgbClr val="2DD4BF"/>
+            </a:solidFill>
+          </a:ln>
+        </p:spPr>
+        <p:style>
+          <a:lnRef idx="1">
+            <a:schemeClr val="accent1"/>
+          </a:lnRef>
+          <a:fillRef idx="3">
+            <a:schemeClr val="accent1"/>
+          </a:fillRef>
+          <a:effectRef idx="2">
+            <a:schemeClr val="accent1"/>
+          </a:effectRef>
+          <a:fontRef idx="minor">
+            <a:schemeClr val="lt1"/>
+          </a:fontRef>
+        </p:style>
+        <p:txBody>
+          <a:bodyPr rtlCol="0" anchor="ctr"/>
+          <a:lstStyle/>
+          <a:p>
+            <a:pPr algn="ctr"/>
+          </a:p>
+        </p:txBody>
+      </p:sp>
+      <p:sp>
+        <p:nvSpPr>
+          <p:cNvPr id="11" name="TextBox 10"/>
+          <p:cNvSpPr txBox="1"/>
+          <p:nvPr/>
+        </p:nvSpPr>
+        <p:spPr>
+          <a:xfrm>
+            <a:off x="6400800" y="1828800"/>
+            <a:ext cx="2103120" cy="4206240"/>
+          </a:xfrm>
+          <a:prstGeom prst="rect">
+            <a:avLst/>
+          </a:prstGeom>
+          <a:noFill/>
+        </p:spPr>
+        <p:txBody>
+          <a:bodyPr wrap="square">
+            <a:spAutoFit/>
+          </a:bodyPr>
+          <a:lstStyle/>
+          <a:p>
+            <a:pPr>
+              <a:defRPr sz="1600" b="1">
+                <a:solidFill>
+                  <a:srgbClr val="2DD4BF"/>
+                </a:solidFill>
+                <a:latin typeface="Arial"/>
+              </a:defRPr>
+            </a:pPr>
+            <a:r>
+              <a:t>[FIELD] Step 3: Rectify</a:t>
+            </a:r>
+          </a:p>
+          <a:p>
+            <a:pPr>
+              <a:spcBef>
+                <a:spcPts val="800"/>
+              </a:spcBef>
+              <a:defRPr sz="1300">
+                <a:solidFill>
+                  <a:srgbClr val="FFFFFF"/>
+                </a:solidFill>
+                <a:latin typeface="Arial"/>
+              </a:defRPr>
+            </a:pPr>
+            <a:r>
+              <a:t>• Field engineers complete physical road/grid repairs.</a:t>
+            </a:r>
+          </a:p>
+          <a:p>
+            <a:pPr>
+              <a:spcBef>
+                <a:spcPts val="800"/>
+              </a:spcBef>
+              <a:defRPr sz="1300">
+                <a:solidFill>
+                  <a:srgbClr val="FFFFFF"/>
+                </a:solidFill>
+                <a:latin typeface="Arial"/>
+              </a:defRPr>
+            </a:pPr>
+            <a:r>
+              <a:t>• Status moved from 'Inspection' to 'Resolved'.</a:t>
+            </a:r>
+          </a:p>
+          <a:p>
+            <a:pPr>
+              <a:spcBef>
+                <a:spcPts val="800"/>
+              </a:spcBef>
+              <a:defRPr sz="1300">
+                <a:solidFill>
+                  <a:srgbClr val="FFFFFF"/>
+                </a:solidFill>
+                <a:latin typeface="Arial"/>
+              </a:defRPr>
+            </a:pPr>
+            <a:r>
+              <a:t>• Official remarks logged into SQLite vault.</a:t>
+            </a:r>
+          </a:p>
+        </p:txBody>
+      </p:sp>
+      <p:sp>
+        <p:nvSpPr>
+          <p:cNvPr id="12" name="Rounded Rectangle 11"/>
+          <p:cNvSpPr/>
+          <p:nvPr/>
+        </p:nvSpPr>
+        <p:spPr>
+          <a:xfrm>
+            <a:off x="8961120" y="1645920"/>
+            <a:ext cx="2468880" cy="4572000"/>
+          </a:xfrm>
+          <a:prstGeom prst="roundRect">
+            <a:avLst/>
+          </a:prstGeom>
+          <a:solidFill>
+            <a:srgbClr val="081C26"/>
+          </a:solidFill>
+          <a:ln w="12700">
+            <a:solidFill>
+              <a:srgbClr val="2DD4BF"/>
+            </a:solidFill>
+          </a:ln>
+        </p:spPr>
+        <p:style>
+          <a:lnRef idx="1">
+            <a:schemeClr val="accent1"/>
+          </a:lnRef>
+          <a:fillRef idx="3">
+            <a:schemeClr val="accent1"/>
+          </a:fillRef>
+          <a:effectRef idx="2">
+            <a:schemeClr val="accent1"/>
+          </a:effectRef>
+          <a:fontRef idx="minor">
+            <a:schemeClr val="lt1"/>
+          </a:fontRef>
+        </p:style>
+        <p:txBody>
+          <a:bodyPr rtlCol="0" anchor="ctr"/>
+          <a:lstStyle/>
+          <a:p>
+            <a:pPr algn="ctr"/>
+          </a:p>
+        </p:txBody>
+      </p:sp>
+      <p:sp>
+        <p:nvSpPr>
+          <p:cNvPr id="13" name="TextBox 12"/>
+          <p:cNvSpPr txBox="1"/>
+          <p:nvPr/>
+        </p:nvSpPr>
+        <p:spPr>
+          <a:xfrm>
+            <a:off x="9144000" y="1828800"/>
+            <a:ext cx="2103120" cy="4206240"/>
+          </a:xfrm>
+          <a:prstGeom prst="rect">
+            <a:avLst/>
+          </a:prstGeom>
+          <a:noFill/>
+        </p:spPr>
+        <p:txBody>
+          <a:bodyPr wrap="square">
+            <a:spAutoFit/>
+          </a:bodyPr>
+          <a:lstStyle/>
+          <a:p>
+            <a:pPr>
+              <a:defRPr sz="1600" b="1">
+                <a:solidFill>
+                  <a:srgbClr val="2DD4BF"/>
+                </a:solidFill>
+                <a:latin typeface="Arial"/>
+              </a:defRPr>
+            </a:pPr>
+            <a:r>
+              <a:t>[CERTIFICATE] Step 4: Certify</a:t>
+            </a:r>
+          </a:p>
+          <a:p>
+            <a:pPr>
+              <a:spcBef>
+                <a:spcPts val="800"/>
+              </a:spcBef>
+              <a:defRPr sz="1300">
+                <a:solidFill>
+                  <a:srgbClr val="FFFFFF"/>
+                </a:solidFill>
+                <a:latin typeface="Arial"/>
+              </a:defRPr>
+            </a:pPr>
+            <a:r>
+              <a:t>• Citizen receives updated status dossier.</a:t>
+            </a:r>
+          </a:p>
+          <a:p>
+            <a:pPr>
+              <a:spcBef>
+                <a:spcPts val="800"/>
+              </a:spcBef>
+              <a:defRPr sz="1300">
+                <a:solidFill>
+                  <a:srgbClr val="FFFFFF"/>
+                </a:solidFill>
+                <a:latin typeface="Arial"/>
+              </a:defRPr>
+            </a:pPr>
+            <a:r>
+              <a:t>• Printable Legal Case Certificate generated.</a:t>
+            </a:r>
+          </a:p>
+          <a:p>
+            <a:pPr>
+              <a:spcBef>
+                <a:spcPts val="800"/>
+              </a:spcBef>
+              <a:defRPr sz="1300">
+                <a:solidFill>
+                  <a:srgbClr val="FFFFFF"/>
+                </a:solidFill>
+                <a:latin typeface="Arial"/>
+              </a:defRPr>
+            </a:pPr>
+            <a:r>
+              <a:t>• Complete audit trail signed &amp; locked.</a:t>
             </a:r>
           </a:p>
         </p:txBody>
@@ -8441,7 +8907,7 @@
               </a:defRPr>
             </a:pPr>
             <a:r>
-              <a:t>VERIFICATION</a:t>
+              <a:t>SYSTEM SECURITY</a:t>
             </a:r>
           </a:p>
         </p:txBody>
@@ -8477,7 +8943,7 @@
               </a:defRPr>
             </a:pPr>
             <a:r>
-              <a:t>Comprehensive Testing &amp; Quality Verification</a:t>
+              <a:t>Security Architecture &amp; Municipal Officer Console</a:t>
             </a:r>
           </a:p>
         </p:txBody>
@@ -8536,7 +9002,7 @@
         <p:spPr>
           <a:xfrm>
             <a:off x="731520" y="1645920"/>
-            <a:ext cx="3383280" cy="4572000"/>
+            <a:ext cx="5120640" cy="4572000"/>
           </a:xfrm>
           <a:prstGeom prst="roundRect">
             <a:avLst/>
@@ -8581,7 +9047,7 @@
         <p:spPr>
           <a:xfrm>
             <a:off x="914400" y="1828800"/>
-            <a:ext cx="3017520" cy="4206240"/>
+            <a:ext cx="4754880" cy="4206240"/>
           </a:xfrm>
           <a:prstGeom prst="rect">
             <a:avLst/>
@@ -8603,55 +9069,71 @@
               </a:defRPr>
             </a:pPr>
             <a:r>
-              <a:t>[FRONTEND] Automated ID Audit</a:t>
-            </a:r>
-          </a:p>
-          <a:p>
-            <a:pPr>
-              <a:spcBef>
-                <a:spcPts val="800"/>
-              </a:spcBef>
-              <a:defRPr sz="1300">
-                <a:solidFill>
-                  <a:srgbClr val="FFFFFF"/>
-                </a:solidFill>
-                <a:latin typeface="Arial"/>
-              </a:defRPr>
-            </a:pPr>
-            <a:r>
-              <a:t>• 111 HTML DOM Element IDs matched with JavaScript controllers.</a:t>
-            </a:r>
-          </a:p>
-          <a:p>
-            <a:pPr>
-              <a:spcBef>
-                <a:spcPts val="800"/>
-              </a:spcBef>
-              <a:defRPr sz="1300">
-                <a:solidFill>
-                  <a:srgbClr val="FFFFFF"/>
-                </a:solidFill>
-                <a:latin typeface="Arial"/>
-              </a:defRPr>
-            </a:pPr>
-            <a:r>
-              <a:t>• 0 missing IDs, 0 null-pointer crashes.</a:t>
-            </a:r>
-          </a:p>
-          <a:p>
-            <a:pPr>
-              <a:spcBef>
-                <a:spcPts val="800"/>
-              </a:spcBef>
-              <a:defRPr sz="1300">
-                <a:solidFill>
-                  <a:srgbClr val="FFFFFF"/>
-                </a:solidFill>
-                <a:latin typeface="Arial"/>
-              </a:defRPr>
-            </a:pPr>
-            <a:r>
-              <a:t>• Tested across modern Chromium, Gecko, and WebKit browsers.</a:t>
+              <a:t>[AUTHENTICATION] Authentication &amp; Access Control</a:t>
+            </a:r>
+          </a:p>
+          <a:p>
+            <a:pPr>
+              <a:spcBef>
+                <a:spcPts val="800"/>
+              </a:spcBef>
+              <a:defRPr sz="1300">
+                <a:solidFill>
+                  <a:srgbClr val="FFFFFF"/>
+                </a:solidFill>
+                <a:latin typeface="Arial"/>
+              </a:defRPr>
+            </a:pPr>
+            <a:r>
+              <a:t>• Role-Based Access Control (RBAC): Strict separation between Citizen and Officer permissions.</a:t>
+            </a:r>
+          </a:p>
+          <a:p>
+            <a:pPr>
+              <a:spcBef>
+                <a:spcPts val="800"/>
+              </a:spcBef>
+              <a:defRPr sz="1300">
+                <a:solidFill>
+                  <a:srgbClr val="FFFFFF"/>
+                </a:solidFill>
+                <a:latin typeface="Arial"/>
+              </a:defRPr>
+            </a:pPr>
+            <a:r>
+              <a:t>• Protected Officer Endpoints: Only authenticated staff can update complaint stages or view full city metrics.</a:t>
+            </a:r>
+          </a:p>
+          <a:p>
+            <a:pPr>
+              <a:spcBef>
+                <a:spcPts val="800"/>
+              </a:spcBef>
+              <a:defRPr sz="1300">
+                <a:solidFill>
+                  <a:srgbClr val="FFFFFF"/>
+                </a:solidFill>
+                <a:latin typeface="Arial"/>
+              </a:defRPr>
+            </a:pPr>
+            <a:r>
+              <a:t>• Secure Token Authentication: 64-character cryptographic hexadecimal bearer tokens.</a:t>
+            </a:r>
+          </a:p>
+          <a:p>
+            <a:pPr>
+              <a:spcBef>
+                <a:spcPts val="800"/>
+              </a:spcBef>
+              <a:defRPr sz="1300">
+                <a:solidFill>
+                  <a:srgbClr val="FFFFFF"/>
+                </a:solidFill>
+                <a:latin typeface="Arial"/>
+              </a:defRPr>
+            </a:pPr>
+            <a:r>
+              <a:t>• Password Hashing: SHA-256 / PBKDF2 with unique cryptographic salt per user.</a:t>
             </a:r>
           </a:p>
         </p:txBody>
@@ -8664,8 +9146,8 @@
         </p:nvSpPr>
         <p:spPr>
           <a:xfrm>
-            <a:off x="4389120" y="1645920"/>
-            <a:ext cx="3383280" cy="4572000"/>
+            <a:off x="6217920" y="1645920"/>
+            <a:ext cx="5120640" cy="4572000"/>
           </a:xfrm>
           <a:prstGeom prst="roundRect">
             <a:avLst/>
@@ -8709,8 +9191,8 @@
         </p:nvSpPr>
         <p:spPr>
           <a:xfrm>
-            <a:off x="4572000" y="1828800"/>
-            <a:ext cx="3017520" cy="4206240"/>
+            <a:off x="6400800" y="1828800"/>
+            <a:ext cx="4754880" cy="4206240"/>
           </a:xfrm>
           <a:prstGeom prst="rect">
             <a:avLst/>
@@ -8732,184 +9214,71 @@
               </a:defRPr>
             </a:pPr>
             <a:r>
-              <a:t>[BACKEND] API Stress Testing</a:t>
-            </a:r>
-          </a:p>
-          <a:p>
-            <a:pPr>
-              <a:spcBef>
-                <a:spcPts val="800"/>
-              </a:spcBef>
-              <a:defRPr sz="1300">
-                <a:solidFill>
-                  <a:srgbClr val="FFFFFF"/>
-                </a:solidFill>
-                <a:latin typeface="Arial"/>
-              </a:defRPr>
-            </a:pPr>
-            <a:r>
-              <a:t>• HTTP 200 OK verified across all 8 REST API endpoints.</a:t>
-            </a:r>
-          </a:p>
-          <a:p>
-            <a:pPr>
-              <a:spcBef>
-                <a:spcPts val="800"/>
-              </a:spcBef>
-              <a:defRPr sz="1300">
-                <a:solidFill>
-                  <a:srgbClr val="FFFFFF"/>
-                </a:solidFill>
-                <a:latin typeface="Arial"/>
-              </a:defRPr>
-            </a:pPr>
-            <a:r>
-              <a:t>• Sub-15ms response latency for SQLite WAL queries.</a:t>
-            </a:r>
-          </a:p>
-          <a:p>
-            <a:pPr>
-              <a:spcBef>
-                <a:spcPts val="800"/>
-              </a:spcBef>
-              <a:defRPr sz="1300">
-                <a:solidFill>
-                  <a:srgbClr val="FFFFFF"/>
-                </a:solidFill>
-                <a:latin typeface="Arial"/>
-              </a:defRPr>
-            </a:pPr>
-            <a:r>
-              <a:t>• Graceful handling of multi-part photo uploads up to 16MB.</a:t>
-            </a:r>
-          </a:p>
-        </p:txBody>
-      </p:sp>
-      <p:sp>
-        <p:nvSpPr>
-          <p:cNvPr id="10" name="Rounded Rectangle 9"/>
-          <p:cNvSpPr/>
-          <p:nvPr/>
-        </p:nvSpPr>
-        <p:spPr>
-          <a:xfrm>
-            <a:off x="8046720" y="1645920"/>
-            <a:ext cx="3383280" cy="4572000"/>
-          </a:xfrm>
-          <a:prstGeom prst="roundRect">
-            <a:avLst/>
-          </a:prstGeom>
-          <a:solidFill>
-            <a:srgbClr val="081C26"/>
-          </a:solidFill>
-          <a:ln w="12700">
-            <a:solidFill>
-              <a:srgbClr val="2DD4BF"/>
-            </a:solidFill>
-          </a:ln>
-        </p:spPr>
-        <p:style>
-          <a:lnRef idx="1">
-            <a:schemeClr val="accent1"/>
-          </a:lnRef>
-          <a:fillRef idx="3">
-            <a:schemeClr val="accent1"/>
-          </a:fillRef>
-          <a:effectRef idx="2">
-            <a:schemeClr val="accent1"/>
-          </a:effectRef>
-          <a:fontRef idx="minor">
-            <a:schemeClr val="lt1"/>
-          </a:fontRef>
-        </p:style>
-        <p:txBody>
-          <a:bodyPr rtlCol="0" anchor="ctr"/>
-          <a:lstStyle/>
-          <a:p>
-            <a:pPr algn="ctr"/>
-          </a:p>
-        </p:txBody>
-      </p:sp>
-      <p:sp>
-        <p:nvSpPr>
-          <p:cNvPr id="11" name="TextBox 10"/>
-          <p:cNvSpPr txBox="1"/>
-          <p:nvPr/>
-        </p:nvSpPr>
-        <p:spPr>
-          <a:xfrm>
-            <a:off x="8229600" y="1828800"/>
-            <a:ext cx="3017520" cy="4206240"/>
-          </a:xfrm>
-          <a:prstGeom prst="rect">
-            <a:avLst/>
-          </a:prstGeom>
-          <a:noFill/>
-        </p:spPr>
-        <p:txBody>
-          <a:bodyPr wrap="square">
-            <a:spAutoFit/>
-          </a:bodyPr>
-          <a:lstStyle/>
-          <a:p>
-            <a:pPr>
-              <a:defRPr sz="1600" b="1">
-                <a:solidFill>
-                  <a:srgbClr val="2DD4BF"/>
-                </a:solidFill>
-                <a:latin typeface="Arial"/>
-              </a:defRPr>
-            </a:pPr>
-            <a:r>
-              <a:t>[STORAGE] Persistence Test</a:t>
-            </a:r>
-          </a:p>
-          <a:p>
-            <a:pPr>
-              <a:spcBef>
-                <a:spcPts val="800"/>
-              </a:spcBef>
-              <a:defRPr sz="1300">
-                <a:solidFill>
-                  <a:srgbClr val="FFFFFF"/>
-                </a:solidFill>
-                <a:latin typeface="Arial"/>
-              </a:defRPr>
-            </a:pPr>
-            <a:r>
-              <a:t>• Server restart survival verified.</a:t>
-            </a:r>
-          </a:p>
-          <a:p>
-            <a:pPr>
-              <a:spcBef>
-                <a:spcPts val="800"/>
-              </a:spcBef>
-              <a:defRPr sz="1300">
-                <a:solidFill>
-                  <a:srgbClr val="FFFFFF"/>
-                </a:solidFill>
-                <a:latin typeface="Arial"/>
-              </a:defRPr>
-            </a:pPr>
-            <a:r>
-              <a:t>• Zero data loss across daemon restarts.</a:t>
-            </a:r>
-          </a:p>
-          <a:p>
-            <a:pPr>
-              <a:spcBef>
-                <a:spcPts val="800"/>
-              </a:spcBef>
-              <a:defRPr sz="1300">
-                <a:solidFill>
-                  <a:srgbClr val="FFFFFF"/>
-                </a:solidFill>
-                <a:latin typeface="Arial"/>
-              </a:defRPr>
-            </a:pPr>
-            <a:r>
-              <a:t>• Git repository synced cleanly to GitHub.</a:t>
+              <a:t>[ADMIN CONSOLE] Officer Administration Console</a:t>
+            </a:r>
+          </a:p>
+          <a:p>
+            <a:pPr>
+              <a:spcBef>
+                <a:spcPts val="800"/>
+              </a:spcBef>
+              <a:defRPr sz="1300">
+                <a:solidFill>
+                  <a:srgbClr val="FFFFFF"/>
+                </a:solidFill>
+                <a:latin typeface="Arial"/>
+              </a:defRPr>
+            </a:pPr>
+            <a:r>
+              <a:t>• Dedicated Admin ID: admin@citizenshield.gov / admin123</a:t>
+            </a:r>
+          </a:p>
+          <a:p>
+            <a:pPr>
+              <a:spcBef>
+                <a:spcPts val="800"/>
+              </a:spcBef>
+              <a:defRPr sz="1300">
+                <a:solidFill>
+                  <a:srgbClr val="FFFFFF"/>
+                </a:solidFill>
+                <a:latin typeface="Arial"/>
+              </a:defRPr>
+            </a:pPr>
+            <a:r>
+              <a:t>• Multi-attribute filtering: Filter complaints by Status, Priority, Category, and all 35 Wards.</a:t>
+            </a:r>
+          </a:p>
+          <a:p>
+            <a:pPr>
+              <a:spcBef>
+                <a:spcPts val="800"/>
+              </a:spcBef>
+              <a:defRPr sz="1300">
+                <a:solidFill>
+                  <a:srgbClr val="FFFFFF"/>
+                </a:solidFill>
+                <a:latin typeface="Arial"/>
+              </a:defRPr>
+            </a:pPr>
+            <a:r>
+              <a:t>• Status Transition Directives: Move complaints from Submitted ➔ Under Review ➔ In Progress ➔ Resolved.</a:t>
+            </a:r>
+          </a:p>
+          <a:p>
+            <a:pPr>
+              <a:spcBef>
+                <a:spcPts val="800"/>
+              </a:spcBef>
+              <a:defRPr sz="1300">
+                <a:solidFill>
+                  <a:srgbClr val="FFFFFF"/>
+                </a:solidFill>
+                <a:latin typeface="Arial"/>
+              </a:defRPr>
+            </a:pPr>
+            <a:r>
+              <a:t>• Audit Logging: Every administrative action logged with timestamp and officer attribution.</a:t>
             </a:r>
           </a:p>
         </p:txBody>

</xml_diff>